<commit_message>
Recompute FPSO Frade CAPEX from REV1 source file
FPSO Frade CAPEX Total now matches the REV1 spreadsheet's own Overview
"Em análise" figure to the cent (US$ 58.733.600,24), using the same
methodology as the rest of the deck: Cost Allocation = CAPEX, status
'Contar' (no TA items present in this dataset), excluding Desenvolvimento
de Produção from the total.

Updates both the consolidated 7-asset deck (new grand total: US$
129.661.920,76) and the standalone FPSO Frade deck.
</commit_message>
<xml_diff>
--- a/PRIO_Plano_Trabalho_CAPEX_2027_Frade.pptx
+++ b/PRIO_Plano_Trabalho_CAPEX_2027_Frade.pptx
@@ -189,7 +189,7 @@
                 <c:formatCode>General</c:formatCode>
                 <c:ptCount val="1"/>
                 <c:pt idx="0">
-                  <c:v>66.26</c:v>
+                  <c:v>58.73</c:v>
                 </c:pt>
               </c:numCache>
             </c:numRef>
@@ -1980,7 +1980,7 @@
                 <a:ea typeface="Cambria" pitchFamily="34" charset="-122"/>
                 <a:cs typeface="Cambria" pitchFamily="34" charset="-120"/>
               </a:rPr>
-              <a:t>US$ 66,3 mi</a:t>
+              <a:t>US$ 58,7 mi</a:t>
             </a:r>
             <a:endParaRPr lang="en-US" sz="2600" dirty="0"/>
           </a:p>
@@ -2119,7 +2119,7 @@
                 <a:ea typeface="Cambria" pitchFamily="34" charset="-122"/>
                 <a:cs typeface="Cambria" pitchFamily="34" charset="-120"/>
               </a:rPr>
-              <a:t>89</a:t>
+              <a:t>71</a:t>
             </a:r>
             <a:endParaRPr lang="en-US" sz="2600" dirty="0"/>
           </a:p>
@@ -2685,7 +2685,7 @@
                             <a:srgbClr val="1C2B33"/>
                           </a:solidFill>
                         </a:rPr>
-                        <a:t>US$ 66,3 mi</a:t>
+                        <a:t>US$ 58,7 mi</a:t>
                       </a:r>
                       <a:endParaRPr lang="en-US" sz="1050" dirty="0"/>
                     </a:p>
@@ -2746,7 +2746,7 @@
                             <a:srgbClr val="1C2B33"/>
                           </a:solidFill>
                         </a:rPr>
-                        <a:t>89</a:t>
+                        <a:t>71</a:t>
                       </a:r>
                       <a:endParaRPr lang="en-US" sz="1050" dirty="0"/>
                     </a:p>
@@ -2870,7 +2870,7 @@
                             <a:srgbClr val="0B2A3D"/>
                           </a:solidFill>
                         </a:rPr>
-                        <a:t>US$ 66,3 mi</a:t>
+                        <a:t>US$ 58,7 mi</a:t>
                       </a:r>
                       <a:endParaRPr lang="en-US" sz="1050" dirty="0"/>
                     </a:p>
@@ -2931,7 +2931,7 @@
                             <a:srgbClr val="0B2A3D"/>
                           </a:solidFill>
                         </a:rPr>
-                        <a:t>89</a:t>
+                        <a:t>71</a:t>
                       </a:r>
                       <a:endParaRPr lang="en-US" sz="1050" dirty="0"/>
                     </a:p>
@@ -3503,7 +3503,7 @@
                 <a:ea typeface="Cambria" pitchFamily="34" charset="-122"/>
                 <a:cs typeface="Cambria" pitchFamily="34" charset="-120"/>
               </a:rPr>
-              <a:t>US$ 66,3 mi</a:t>
+              <a:t>US$ 58,7 mi</a:t>
             </a:r>
             <a:endParaRPr lang="en-US" sz="3300" dirty="0"/>
           </a:p>
@@ -3642,7 +3642,7 @@
                 <a:ea typeface="Cambria" pitchFamily="34" charset="-122"/>
                 <a:cs typeface="Cambria" pitchFamily="34" charset="-120"/>
               </a:rPr>
-              <a:t>US$ 30,4 mi</a:t>
+              <a:t>US$ 25,5 mi</a:t>
             </a:r>
             <a:endParaRPr lang="en-US" sz="2600" dirty="0"/>
           </a:p>
@@ -3742,7 +3742,7 @@
                 <a:ea typeface="Cambria" pitchFamily="34" charset="-122"/>
                 <a:cs typeface="Cambria" pitchFamily="34" charset="-120"/>
               </a:rPr>
-              <a:t>US$ 35,9 mi</a:t>
+              <a:t>US$ 33,2 mi</a:t>
             </a:r>
             <a:endParaRPr lang="en-US" sz="2600" dirty="0"/>
           </a:p>
@@ -3921,7 +3921,7 @@
                 <a:ea typeface="Calibri" pitchFamily="34" charset="-122"/>
                 <a:cs typeface="Calibri" pitchFamily="34" charset="-120"/>
               </a:rPr>
-              <a:t>US$ 24,9 mi</a:t>
+              <a:t>US$ 21,1 mi</a:t>
             </a:r>
             <a:endParaRPr lang="en-US" sz="950" dirty="0"/>
           </a:p>
@@ -4195,7 +4195,7 @@
                 <a:ea typeface="Calibri" pitchFamily="34" charset="-122"/>
                 <a:cs typeface="Calibri" pitchFamily="34" charset="-120"/>
               </a:rPr>
-              <a:t>US$ 3,8 mi</a:t>
+              <a:t>US$ 2,1 mi</a:t>
             </a:r>
             <a:endParaRPr lang="en-US" sz="950" dirty="0"/>
           </a:p>
@@ -4234,7 +4234,7 @@
                 <a:ea typeface="Calibri" pitchFamily="34" charset="-122"/>
                 <a:cs typeface="Calibri" pitchFamily="34" charset="-120"/>
               </a:rPr>
-              <a:t>INT - Integridade</a:t>
+              <a:t>ADM - Administrativo</a:t>
             </a:r>
             <a:endParaRPr lang="en-US" sz="950" dirty="0"/>
           </a:p>
@@ -4332,7 +4332,7 @@
                 <a:ea typeface="Calibri" pitchFamily="34" charset="-122"/>
                 <a:cs typeface="Calibri" pitchFamily="34" charset="-120"/>
               </a:rPr>
-              <a:t>ADM - Administrativo</a:t>
+              <a:t>P&amp;Q - Processos</a:t>
             </a:r>
             <a:endParaRPr lang="en-US" sz="950" dirty="0"/>
           </a:p>
@@ -4371,7 +4371,7 @@
                 <a:ea typeface="Calibri" pitchFamily="34" charset="-122"/>
                 <a:cs typeface="Calibri" pitchFamily="34" charset="-120"/>
               </a:rPr>
-              <a:t>US$ 2,1 mi</a:t>
+              <a:t>US$ 1,8 mi</a:t>
             </a:r>
             <a:endParaRPr lang="en-US" sz="950" dirty="0"/>
           </a:p>
@@ -4410,7 +4410,7 @@
                 <a:ea typeface="Calibri" pitchFamily="34" charset="-122"/>
                 <a:cs typeface="Calibri" pitchFamily="34" charset="-120"/>
               </a:rPr>
-              <a:t>P&amp;Q - Processos</a:t>
+              <a:t>P&amp;Q - Químicos</a:t>
             </a:r>
             <a:endParaRPr lang="en-US" sz="950" dirty="0"/>
           </a:p>
@@ -4449,7 +4449,7 @@
                 <a:ea typeface="Calibri" pitchFamily="34" charset="-122"/>
                 <a:cs typeface="Calibri" pitchFamily="34" charset="-120"/>
               </a:rPr>
-              <a:t>US$ 2,0 mi</a:t>
+              <a:t>US$ 1,1 mi</a:t>
             </a:r>
             <a:endParaRPr lang="en-US" sz="950" dirty="0"/>
           </a:p>
@@ -4508,7 +4508,7 @@
                 <a:ea typeface="Calibri" pitchFamily="34" charset="-122"/>
                 <a:cs typeface="Calibri" pitchFamily="34" charset="-120"/>
               </a:rPr>
-              <a:t>P&amp;Q - Químicos</a:t>
+              <a:t>MET – Medição</a:t>
             </a:r>
             <a:endParaRPr lang="en-US" sz="950" dirty="0"/>
           </a:p>
@@ -4547,7 +4547,7 @@
                 <a:ea typeface="Calibri" pitchFamily="34" charset="-122"/>
                 <a:cs typeface="Calibri" pitchFamily="34" charset="-120"/>
               </a:rPr>
-              <a:t>US$ 1,1 mi</a:t>
+              <a:t>US$ 822,3 mil</a:t>
             </a:r>
             <a:endParaRPr lang="en-US" sz="950" dirty="0"/>
           </a:p>
@@ -4586,7 +4586,7 @@
                 <a:ea typeface="Calibri" pitchFamily="34" charset="-122"/>
                 <a:cs typeface="Calibri" pitchFamily="34" charset="-120"/>
               </a:rPr>
-              <a:t>MET – Medição</a:t>
+              <a:t>INT - Integridade</a:t>
             </a:r>
             <a:endParaRPr lang="en-US" sz="950" dirty="0"/>
           </a:p>
@@ -4625,7 +4625,7 @@
                 <a:ea typeface="Calibri" pitchFamily="34" charset="-122"/>
                 <a:cs typeface="Calibri" pitchFamily="34" charset="-120"/>
               </a:rPr>
-              <a:t>US$ 822,3 mil</a:t>
+              <a:t>US$ 411,6 mil</a:t>
             </a:r>
             <a:endParaRPr lang="en-US" sz="950" dirty="0"/>
           </a:p>
@@ -4824,7 +4824,7 @@
                 <a:ea typeface="Calibri" pitchFamily="34" charset="-122"/>
                 <a:cs typeface="Calibri" pitchFamily="34" charset="-120"/>
               </a:rPr>
-              <a:t>Bem Estar/Segurança</a:t>
+              <a:t>Rotina Operacional</a:t>
             </a:r>
             <a:endParaRPr lang="en-US" sz="950" dirty="0"/>
           </a:p>
@@ -4863,7 +4863,7 @@
                 <a:ea typeface="Calibri" pitchFamily="34" charset="-122"/>
                 <a:cs typeface="Calibri" pitchFamily="34" charset="-120"/>
               </a:rPr>
-              <a:t>US$ 22,7 mi</a:t>
+              <a:t>US$ 17,0 mi</a:t>
             </a:r>
             <a:endParaRPr lang="en-US" sz="950" dirty="0"/>
           </a:p>
@@ -4922,7 +4922,7 @@
                 <a:ea typeface="Calibri" pitchFamily="34" charset="-122"/>
                 <a:cs typeface="Calibri" pitchFamily="34" charset="-120"/>
               </a:rPr>
-              <a:t>Rotina Operacional</a:t>
+              <a:t>Bem Estar/Segurança</a:t>
             </a:r>
             <a:endParaRPr lang="en-US" sz="950" dirty="0"/>
           </a:p>
@@ -4961,7 +4961,7 @@
                 <a:ea typeface="Calibri" pitchFamily="34" charset="-122"/>
                 <a:cs typeface="Calibri" pitchFamily="34" charset="-120"/>
               </a:rPr>
-              <a:t>US$ 17,4 mi</a:t>
+              <a:t>US$ 17,0 mi</a:t>
             </a:r>
             <a:endParaRPr lang="en-US" sz="950" dirty="0"/>
           </a:p>
@@ -5039,7 +5039,7 @@
                 <a:ea typeface="Calibri" pitchFamily="34" charset="-122"/>
                 <a:cs typeface="Calibri" pitchFamily="34" charset="-120"/>
               </a:rPr>
-              <a:t>US$ 15,0 mi</a:t>
+              <a:t>US$ 13,3 mi</a:t>
             </a:r>
             <a:endParaRPr lang="en-US" sz="950" dirty="0"/>
           </a:p>
@@ -5137,7 +5137,7 @@
                 <a:ea typeface="Calibri" pitchFamily="34" charset="-122"/>
                 <a:cs typeface="Calibri" pitchFamily="34" charset="-120"/>
               </a:rPr>
-              <a:t>US$ 11,2 mi</a:t>
+              <a:t>US$ 11,4 mi</a:t>
             </a:r>
             <a:endParaRPr lang="en-US" sz="950" dirty="0"/>
           </a:p>
@@ -5338,7 +5338,7 @@
                 <a:ea typeface="Calibri" pitchFamily="34" charset="-122"/>
                 <a:cs typeface="Calibri" pitchFamily="34" charset="-120"/>
               </a:rPr>
-              <a:t>Principais escopos por valor · 89 itens no total</a:t>
+              <a:t>Principais escopos por valor · 71 itens no total</a:t>
             </a:r>
             <a:endParaRPr lang="en-US" sz="1250" dirty="0"/>
           </a:p>
@@ -5664,6 +5664,280 @@
                           <a:ea typeface="Calibri" pitchFamily="34" charset="-122"/>
                           <a:cs typeface="Calibri" pitchFamily="34" charset="-120"/>
                         </a:rPr>
+                        <a:t>SUBSTITUIÇÃO DOS BOOGIES DO TURRET</a:t>
+                      </a:r>
+                      <a:endParaRPr lang="en-US" sz="1000" dirty="0">
+                        <a:latin typeface="Calibri" charset="0"/>
+                        <a:ea typeface="Calibri" charset="0"/>
+                        <a:cs typeface="Calibri" charset="0"/>
+                      </a:endParaRPr>
+                    </a:p>
+                  </a:txBody>
+                  <a:tcPr marL="91440" marR="91440" marT="45720" marB="45720" anchor="ctr">
+                    <a:lnL w="6350" cap="flat" cmpd="sng" algn="ctr">
+                      <a:solidFill>
+                        <a:srgbClr val="E3E8E9"/>
+                      </a:solidFill>
+                      <a:prstDash val="solid"/>
+                      <a:round/>
+                      <a:headEnd type="none" w="med" len="med"/>
+                      <a:tailEnd type="none" w="med" len="med"/>
+                    </a:lnL>
+                    <a:lnR w="6350" cap="flat" cmpd="sng" algn="ctr">
+                      <a:solidFill>
+                        <a:srgbClr val="E3E8E9"/>
+                      </a:solidFill>
+                      <a:prstDash val="solid"/>
+                      <a:round/>
+                      <a:headEnd type="none" w="med" len="med"/>
+                      <a:tailEnd type="none" w="med" len="med"/>
+                    </a:lnR>
+                    <a:lnT w="6350" cap="flat" cmpd="sng" algn="ctr">
+                      <a:solidFill>
+                        <a:srgbClr val="E3E8E9"/>
+                      </a:solidFill>
+                      <a:prstDash val="solid"/>
+                      <a:round/>
+                      <a:headEnd type="none" w="med" len="med"/>
+                      <a:tailEnd type="none" w="med" len="med"/>
+                    </a:lnT>
+                    <a:lnB w="6350" cap="flat" cmpd="sng" algn="ctr">
+                      <a:solidFill>
+                        <a:srgbClr val="E3E8E9"/>
+                      </a:solidFill>
+                      <a:prstDash val="solid"/>
+                      <a:round/>
+                      <a:headEnd type="none" w="med" len="med"/>
+                      <a:tailEnd type="none" w="med" len="med"/>
+                    </a:lnB>
+                    <a:solidFill>
+                      <a:srgbClr val="FFFFFF"/>
+                    </a:solidFill>
+                  </a:tcPr>
+                </a:tc>
+                <a:tc>
+                  <a:txBody>
+                    <a:bodyPr/>
+                    <a:lstStyle/>
+                    <a:p>
+                      <a:pPr indent="0" marL="0">
+                        <a:buNone/>
+                      </a:pPr>
+                      <a:r>
+                        <a:rPr lang="en-US" sz="950" dirty="0">
+                          <a:solidFill>
+                            <a:srgbClr val="5B6B73"/>
+                          </a:solidFill>
+                          <a:latin typeface="Calibri" pitchFamily="34" charset="0"/>
+                          <a:ea typeface="Calibri" pitchFamily="34" charset="-122"/>
+                          <a:cs typeface="Calibri" pitchFamily="34" charset="-120"/>
+                        </a:rPr>
+                        <a:t>Integridade e Regulatório</a:t>
+                      </a:r>
+                      <a:endParaRPr lang="en-US" sz="950" dirty="0">
+                        <a:latin typeface="Calibri" charset="0"/>
+                        <a:ea typeface="Calibri" charset="0"/>
+                        <a:cs typeface="Calibri" charset="0"/>
+                      </a:endParaRPr>
+                    </a:p>
+                  </a:txBody>
+                  <a:tcPr marL="91440" marR="91440" marT="45720" marB="45720" anchor="ctr">
+                    <a:lnL w="6350" cap="flat" cmpd="sng" algn="ctr">
+                      <a:solidFill>
+                        <a:srgbClr val="E3E8E9"/>
+                      </a:solidFill>
+                      <a:prstDash val="solid"/>
+                      <a:round/>
+                      <a:headEnd type="none" w="med" len="med"/>
+                      <a:tailEnd type="none" w="med" len="med"/>
+                    </a:lnL>
+                    <a:lnR w="6350" cap="flat" cmpd="sng" algn="ctr">
+                      <a:solidFill>
+                        <a:srgbClr val="E3E8E9"/>
+                      </a:solidFill>
+                      <a:prstDash val="solid"/>
+                      <a:round/>
+                      <a:headEnd type="none" w="med" len="med"/>
+                      <a:tailEnd type="none" w="med" len="med"/>
+                    </a:lnR>
+                    <a:lnT w="6350" cap="flat" cmpd="sng" algn="ctr">
+                      <a:solidFill>
+                        <a:srgbClr val="E3E8E9"/>
+                      </a:solidFill>
+                      <a:prstDash val="solid"/>
+                      <a:round/>
+                      <a:headEnd type="none" w="med" len="med"/>
+                      <a:tailEnd type="none" w="med" len="med"/>
+                    </a:lnT>
+                    <a:lnB w="6350" cap="flat" cmpd="sng" algn="ctr">
+                      <a:solidFill>
+                        <a:srgbClr val="E3E8E9"/>
+                      </a:solidFill>
+                      <a:prstDash val="solid"/>
+                      <a:round/>
+                      <a:headEnd type="none" w="med" len="med"/>
+                      <a:tailEnd type="none" w="med" len="med"/>
+                    </a:lnB>
+                    <a:solidFill>
+                      <a:srgbClr val="FFFFFF"/>
+                    </a:solidFill>
+                  </a:tcPr>
+                </a:tc>
+                <a:tc>
+                  <a:txBody>
+                    <a:bodyPr/>
+                    <a:lstStyle/>
+                    <a:p>
+                      <a:pPr indent="0" marL="0">
+                        <a:buNone/>
+                      </a:pPr>
+                      <a:r>
+                        <a:rPr lang="en-US" sz="950" dirty="0">
+                          <a:solidFill>
+                            <a:srgbClr val="5B6B73"/>
+                          </a:solidFill>
+                          <a:latin typeface="Calibri" pitchFamily="34" charset="0"/>
+                          <a:ea typeface="Calibri" pitchFamily="34" charset="-122"/>
+                          <a:cs typeface="Calibri" pitchFamily="34" charset="-120"/>
+                        </a:rPr>
+                        <a:t>NAV - Naval</a:t>
+                      </a:r>
+                      <a:endParaRPr lang="en-US" sz="950" dirty="0">
+                        <a:latin typeface="Calibri" charset="0"/>
+                        <a:ea typeface="Calibri" charset="0"/>
+                        <a:cs typeface="Calibri" charset="0"/>
+                      </a:endParaRPr>
+                    </a:p>
+                  </a:txBody>
+                  <a:tcPr marL="91440" marR="91440" marT="45720" marB="45720" anchor="ctr">
+                    <a:lnL w="6350" cap="flat" cmpd="sng" algn="ctr">
+                      <a:solidFill>
+                        <a:srgbClr val="E3E8E9"/>
+                      </a:solidFill>
+                      <a:prstDash val="solid"/>
+                      <a:round/>
+                      <a:headEnd type="none" w="med" len="med"/>
+                      <a:tailEnd type="none" w="med" len="med"/>
+                    </a:lnL>
+                    <a:lnR w="6350" cap="flat" cmpd="sng" algn="ctr">
+                      <a:solidFill>
+                        <a:srgbClr val="E3E8E9"/>
+                      </a:solidFill>
+                      <a:prstDash val="solid"/>
+                      <a:round/>
+                      <a:headEnd type="none" w="med" len="med"/>
+                      <a:tailEnd type="none" w="med" len="med"/>
+                    </a:lnR>
+                    <a:lnT w="6350" cap="flat" cmpd="sng" algn="ctr">
+                      <a:solidFill>
+                        <a:srgbClr val="E3E8E9"/>
+                      </a:solidFill>
+                      <a:prstDash val="solid"/>
+                      <a:round/>
+                      <a:headEnd type="none" w="med" len="med"/>
+                      <a:tailEnd type="none" w="med" len="med"/>
+                    </a:lnT>
+                    <a:lnB w="6350" cap="flat" cmpd="sng" algn="ctr">
+                      <a:solidFill>
+                        <a:srgbClr val="E3E8E9"/>
+                      </a:solidFill>
+                      <a:prstDash val="solid"/>
+                      <a:round/>
+                      <a:headEnd type="none" w="med" len="med"/>
+                      <a:tailEnd type="none" w="med" len="med"/>
+                    </a:lnB>
+                    <a:solidFill>
+                      <a:srgbClr val="FFFFFF"/>
+                    </a:solidFill>
+                  </a:tcPr>
+                </a:tc>
+                <a:tc>
+                  <a:txBody>
+                    <a:bodyPr/>
+                    <a:lstStyle/>
+                    <a:p>
+                      <a:pPr algn="r" indent="0" marL="0">
+                        <a:buNone/>
+                      </a:pPr>
+                      <a:r>
+                        <a:rPr lang="en-US" sz="1000" b="1" dirty="0">
+                          <a:solidFill>
+                            <a:srgbClr val="0B2A3D"/>
+                          </a:solidFill>
+                          <a:latin typeface="Calibri" pitchFamily="34" charset="0"/>
+                          <a:ea typeface="Calibri" pitchFamily="34" charset="-122"/>
+                          <a:cs typeface="Calibri" pitchFamily="34" charset="-120"/>
+                        </a:rPr>
+                        <a:t>US$ 11,4 mi</a:t>
+                      </a:r>
+                      <a:endParaRPr lang="en-US" sz="1000" dirty="0">
+                        <a:latin typeface="Calibri" charset="0"/>
+                        <a:ea typeface="Calibri" charset="0"/>
+                        <a:cs typeface="Calibri" charset="0"/>
+                      </a:endParaRPr>
+                    </a:p>
+                  </a:txBody>
+                  <a:tcPr marL="91440" marR="91440" marT="45720" marB="45720" anchor="ctr">
+                    <a:lnL w="6350" cap="flat" cmpd="sng" algn="ctr">
+                      <a:solidFill>
+                        <a:srgbClr val="E3E8E9"/>
+                      </a:solidFill>
+                      <a:prstDash val="solid"/>
+                      <a:round/>
+                      <a:headEnd type="none" w="med" len="med"/>
+                      <a:tailEnd type="none" w="med" len="med"/>
+                    </a:lnL>
+                    <a:lnR w="6350" cap="flat" cmpd="sng" algn="ctr">
+                      <a:solidFill>
+                        <a:srgbClr val="E3E8E9"/>
+                      </a:solidFill>
+                      <a:prstDash val="solid"/>
+                      <a:round/>
+                      <a:headEnd type="none" w="med" len="med"/>
+                      <a:tailEnd type="none" w="med" len="med"/>
+                    </a:lnR>
+                    <a:lnT w="6350" cap="flat" cmpd="sng" algn="ctr">
+                      <a:solidFill>
+                        <a:srgbClr val="E3E8E9"/>
+                      </a:solidFill>
+                      <a:prstDash val="solid"/>
+                      <a:round/>
+                      <a:headEnd type="none" w="med" len="med"/>
+                      <a:tailEnd type="none" w="med" len="med"/>
+                    </a:lnT>
+                    <a:lnB w="6350" cap="flat" cmpd="sng" algn="ctr">
+                      <a:solidFill>
+                        <a:srgbClr val="E3E8E9"/>
+                      </a:solidFill>
+                      <a:prstDash val="solid"/>
+                      <a:round/>
+                      <a:headEnd type="none" w="med" len="med"/>
+                      <a:tailEnd type="none" w="med" len="med"/>
+                    </a:lnB>
+                    <a:solidFill>
+                      <a:srgbClr val="FFFFFF"/>
+                    </a:solidFill>
+                  </a:tcPr>
+                </a:tc>
+              </a:tr>
+              <a:tr h="288036">
+                <a:tc>
+                  <a:txBody>
+                    <a:bodyPr/>
+                    <a:lstStyle/>
+                    <a:p>
+                      <a:pPr indent="0" marL="0">
+                        <a:buNone/>
+                      </a:pPr>
+                      <a:r>
+                        <a:rPr lang="en-US" sz="1000" dirty="0">
+                          <a:solidFill>
+                            <a:srgbClr val="1C2B33"/>
+                          </a:solidFill>
+                          <a:latin typeface="Calibri" pitchFamily="34" charset="0"/>
+                          <a:ea typeface="Calibri" pitchFamily="34" charset="-122"/>
+                          <a:cs typeface="Calibri" pitchFamily="34" charset="-120"/>
+                        </a:rPr>
                         <a:t>Guincho de Pull In + Reforma do Turret</a:t>
                       </a:r>
                       <a:endParaRPr lang="en-US" sz="1000" dirty="0">
@@ -5711,7 +5985,7 @@
                       <a:tailEnd type="none" w="med" len="med"/>
                     </a:lnB>
                     <a:solidFill>
-                      <a:srgbClr val="FFFFFF"/>
+                      <a:srgbClr val="F0F4F5"/>
                     </a:solidFill>
                   </a:tcPr>
                 </a:tc>
@@ -5779,7 +6053,7 @@
                       <a:tailEnd type="none" w="med" len="med"/>
                     </a:lnB>
                     <a:solidFill>
-                      <a:srgbClr val="FFFFFF"/>
+                      <a:srgbClr val="F0F4F5"/>
                     </a:solidFill>
                   </a:tcPr>
                 </a:tc>
@@ -5847,280 +6121,6 @@
                       <a:tailEnd type="none" w="med" len="med"/>
                     </a:lnB>
                     <a:solidFill>
-                      <a:srgbClr val="FFFFFF"/>
-                    </a:solidFill>
-                  </a:tcPr>
-                </a:tc>
-                <a:tc>
-                  <a:txBody>
-                    <a:bodyPr/>
-                    <a:lstStyle/>
-                    <a:p>
-                      <a:pPr algn="r" indent="0" marL="0">
-                        <a:buNone/>
-                      </a:pPr>
-                      <a:r>
-                        <a:rPr lang="en-US" sz="1000" b="1" dirty="0">
-                          <a:solidFill>
-                            <a:srgbClr val="0B2A3D"/>
-                          </a:solidFill>
-                          <a:latin typeface="Calibri" pitchFamily="34" charset="0"/>
-                          <a:ea typeface="Calibri" pitchFamily="34" charset="-122"/>
-                          <a:cs typeface="Calibri" pitchFamily="34" charset="-120"/>
-                        </a:rPr>
-                        <a:t>US$ 11,6 mi</a:t>
-                      </a:r>
-                      <a:endParaRPr lang="en-US" sz="1000" dirty="0">
-                        <a:latin typeface="Calibri" charset="0"/>
-                        <a:ea typeface="Calibri" charset="0"/>
-                        <a:cs typeface="Calibri" charset="0"/>
-                      </a:endParaRPr>
-                    </a:p>
-                  </a:txBody>
-                  <a:tcPr marL="91440" marR="91440" marT="45720" marB="45720" anchor="ctr">
-                    <a:lnL w="6350" cap="flat" cmpd="sng" algn="ctr">
-                      <a:solidFill>
-                        <a:srgbClr val="E3E8E9"/>
-                      </a:solidFill>
-                      <a:prstDash val="solid"/>
-                      <a:round/>
-                      <a:headEnd type="none" w="med" len="med"/>
-                      <a:tailEnd type="none" w="med" len="med"/>
-                    </a:lnL>
-                    <a:lnR w="6350" cap="flat" cmpd="sng" algn="ctr">
-                      <a:solidFill>
-                        <a:srgbClr val="E3E8E9"/>
-                      </a:solidFill>
-                      <a:prstDash val="solid"/>
-                      <a:round/>
-                      <a:headEnd type="none" w="med" len="med"/>
-                      <a:tailEnd type="none" w="med" len="med"/>
-                    </a:lnR>
-                    <a:lnT w="6350" cap="flat" cmpd="sng" algn="ctr">
-                      <a:solidFill>
-                        <a:srgbClr val="E3E8E9"/>
-                      </a:solidFill>
-                      <a:prstDash val="solid"/>
-                      <a:round/>
-                      <a:headEnd type="none" w="med" len="med"/>
-                      <a:tailEnd type="none" w="med" len="med"/>
-                    </a:lnT>
-                    <a:lnB w="6350" cap="flat" cmpd="sng" algn="ctr">
-                      <a:solidFill>
-                        <a:srgbClr val="E3E8E9"/>
-                      </a:solidFill>
-                      <a:prstDash val="solid"/>
-                      <a:round/>
-                      <a:headEnd type="none" w="med" len="med"/>
-                      <a:tailEnd type="none" w="med" len="med"/>
-                    </a:lnB>
-                    <a:solidFill>
-                      <a:srgbClr val="FFFFFF"/>
-                    </a:solidFill>
-                  </a:tcPr>
-                </a:tc>
-              </a:tr>
-              <a:tr h="288036">
-                <a:tc>
-                  <a:txBody>
-                    <a:bodyPr/>
-                    <a:lstStyle/>
-                    <a:p>
-                      <a:pPr indent="0" marL="0">
-                        <a:buNone/>
-                      </a:pPr>
-                      <a:r>
-                        <a:rPr lang="en-US" sz="1000" dirty="0">
-                          <a:solidFill>
-                            <a:srgbClr val="1C2B33"/>
-                          </a:solidFill>
-                          <a:latin typeface="Calibri" pitchFamily="34" charset="0"/>
-                          <a:ea typeface="Calibri" pitchFamily="34" charset="-122"/>
-                          <a:cs typeface="Calibri" pitchFamily="34" charset="-120"/>
-                        </a:rPr>
-                        <a:t>SUBSTITUIÇÃO DOS BOOGIES DO TURRET</a:t>
-                      </a:r>
-                      <a:endParaRPr lang="en-US" sz="1000" dirty="0">
-                        <a:latin typeface="Calibri" charset="0"/>
-                        <a:ea typeface="Calibri" charset="0"/>
-                        <a:cs typeface="Calibri" charset="0"/>
-                      </a:endParaRPr>
-                    </a:p>
-                  </a:txBody>
-                  <a:tcPr marL="91440" marR="91440" marT="45720" marB="45720" anchor="ctr">
-                    <a:lnL w="6350" cap="flat" cmpd="sng" algn="ctr">
-                      <a:solidFill>
-                        <a:srgbClr val="E3E8E9"/>
-                      </a:solidFill>
-                      <a:prstDash val="solid"/>
-                      <a:round/>
-                      <a:headEnd type="none" w="med" len="med"/>
-                      <a:tailEnd type="none" w="med" len="med"/>
-                    </a:lnL>
-                    <a:lnR w="6350" cap="flat" cmpd="sng" algn="ctr">
-                      <a:solidFill>
-                        <a:srgbClr val="E3E8E9"/>
-                      </a:solidFill>
-                      <a:prstDash val="solid"/>
-                      <a:round/>
-                      <a:headEnd type="none" w="med" len="med"/>
-                      <a:tailEnd type="none" w="med" len="med"/>
-                    </a:lnR>
-                    <a:lnT w="6350" cap="flat" cmpd="sng" algn="ctr">
-                      <a:solidFill>
-                        <a:srgbClr val="E3E8E9"/>
-                      </a:solidFill>
-                      <a:prstDash val="solid"/>
-                      <a:round/>
-                      <a:headEnd type="none" w="med" len="med"/>
-                      <a:tailEnd type="none" w="med" len="med"/>
-                    </a:lnT>
-                    <a:lnB w="6350" cap="flat" cmpd="sng" algn="ctr">
-                      <a:solidFill>
-                        <a:srgbClr val="E3E8E9"/>
-                      </a:solidFill>
-                      <a:prstDash val="solid"/>
-                      <a:round/>
-                      <a:headEnd type="none" w="med" len="med"/>
-                      <a:tailEnd type="none" w="med" len="med"/>
-                    </a:lnB>
-                    <a:solidFill>
-                      <a:srgbClr val="F0F4F5"/>
-                    </a:solidFill>
-                  </a:tcPr>
-                </a:tc>
-                <a:tc>
-                  <a:txBody>
-                    <a:bodyPr/>
-                    <a:lstStyle/>
-                    <a:p>
-                      <a:pPr indent="0" marL="0">
-                        <a:buNone/>
-                      </a:pPr>
-                      <a:r>
-                        <a:rPr lang="en-US" sz="950" dirty="0">
-                          <a:solidFill>
-                            <a:srgbClr val="5B6B73"/>
-                          </a:solidFill>
-                          <a:latin typeface="Calibri" pitchFamily="34" charset="0"/>
-                          <a:ea typeface="Calibri" pitchFamily="34" charset="-122"/>
-                          <a:cs typeface="Calibri" pitchFamily="34" charset="-120"/>
-                        </a:rPr>
-                        <a:t>Integridade e Regulatório</a:t>
-                      </a:r>
-                      <a:endParaRPr lang="en-US" sz="950" dirty="0">
-                        <a:latin typeface="Calibri" charset="0"/>
-                        <a:ea typeface="Calibri" charset="0"/>
-                        <a:cs typeface="Calibri" charset="0"/>
-                      </a:endParaRPr>
-                    </a:p>
-                  </a:txBody>
-                  <a:tcPr marL="91440" marR="91440" marT="45720" marB="45720" anchor="ctr">
-                    <a:lnL w="6350" cap="flat" cmpd="sng" algn="ctr">
-                      <a:solidFill>
-                        <a:srgbClr val="E3E8E9"/>
-                      </a:solidFill>
-                      <a:prstDash val="solid"/>
-                      <a:round/>
-                      <a:headEnd type="none" w="med" len="med"/>
-                      <a:tailEnd type="none" w="med" len="med"/>
-                    </a:lnL>
-                    <a:lnR w="6350" cap="flat" cmpd="sng" algn="ctr">
-                      <a:solidFill>
-                        <a:srgbClr val="E3E8E9"/>
-                      </a:solidFill>
-                      <a:prstDash val="solid"/>
-                      <a:round/>
-                      <a:headEnd type="none" w="med" len="med"/>
-                      <a:tailEnd type="none" w="med" len="med"/>
-                    </a:lnR>
-                    <a:lnT w="6350" cap="flat" cmpd="sng" algn="ctr">
-                      <a:solidFill>
-                        <a:srgbClr val="E3E8E9"/>
-                      </a:solidFill>
-                      <a:prstDash val="solid"/>
-                      <a:round/>
-                      <a:headEnd type="none" w="med" len="med"/>
-                      <a:tailEnd type="none" w="med" len="med"/>
-                    </a:lnT>
-                    <a:lnB w="6350" cap="flat" cmpd="sng" algn="ctr">
-                      <a:solidFill>
-                        <a:srgbClr val="E3E8E9"/>
-                      </a:solidFill>
-                      <a:prstDash val="solid"/>
-                      <a:round/>
-                      <a:headEnd type="none" w="med" len="med"/>
-                      <a:tailEnd type="none" w="med" len="med"/>
-                    </a:lnB>
-                    <a:solidFill>
-                      <a:srgbClr val="F0F4F5"/>
-                    </a:solidFill>
-                  </a:tcPr>
-                </a:tc>
-                <a:tc>
-                  <a:txBody>
-                    <a:bodyPr/>
-                    <a:lstStyle/>
-                    <a:p>
-                      <a:pPr indent="0" marL="0">
-                        <a:buNone/>
-                      </a:pPr>
-                      <a:r>
-                        <a:rPr lang="en-US" sz="950" dirty="0">
-                          <a:solidFill>
-                            <a:srgbClr val="5B6B73"/>
-                          </a:solidFill>
-                          <a:latin typeface="Calibri" pitchFamily="34" charset="0"/>
-                          <a:ea typeface="Calibri" pitchFamily="34" charset="-122"/>
-                          <a:cs typeface="Calibri" pitchFamily="34" charset="-120"/>
-                        </a:rPr>
-                        <a:t>NAV - Naval</a:t>
-                      </a:r>
-                      <a:endParaRPr lang="en-US" sz="950" dirty="0">
-                        <a:latin typeface="Calibri" charset="0"/>
-                        <a:ea typeface="Calibri" charset="0"/>
-                        <a:cs typeface="Calibri" charset="0"/>
-                      </a:endParaRPr>
-                    </a:p>
-                  </a:txBody>
-                  <a:tcPr marL="91440" marR="91440" marT="45720" marB="45720" anchor="ctr">
-                    <a:lnL w="6350" cap="flat" cmpd="sng" algn="ctr">
-                      <a:solidFill>
-                        <a:srgbClr val="E3E8E9"/>
-                      </a:solidFill>
-                      <a:prstDash val="solid"/>
-                      <a:round/>
-                      <a:headEnd type="none" w="med" len="med"/>
-                      <a:tailEnd type="none" w="med" len="med"/>
-                    </a:lnL>
-                    <a:lnR w="6350" cap="flat" cmpd="sng" algn="ctr">
-                      <a:solidFill>
-                        <a:srgbClr val="E3E8E9"/>
-                      </a:solidFill>
-                      <a:prstDash val="solid"/>
-                      <a:round/>
-                      <a:headEnd type="none" w="med" len="med"/>
-                      <a:tailEnd type="none" w="med" len="med"/>
-                    </a:lnR>
-                    <a:lnT w="6350" cap="flat" cmpd="sng" algn="ctr">
-                      <a:solidFill>
-                        <a:srgbClr val="E3E8E9"/>
-                      </a:solidFill>
-                      <a:prstDash val="solid"/>
-                      <a:round/>
-                      <a:headEnd type="none" w="med" len="med"/>
-                      <a:tailEnd type="none" w="med" len="med"/>
-                    </a:lnT>
-                    <a:lnB w="6350" cap="flat" cmpd="sng" algn="ctr">
-                      <a:solidFill>
-                        <a:srgbClr val="E3E8E9"/>
-                      </a:solidFill>
-                      <a:prstDash val="solid"/>
-                      <a:round/>
-                      <a:headEnd type="none" w="med" len="med"/>
-                      <a:tailEnd type="none" w="med" len="med"/>
-                    </a:lnB>
-                    <a:solidFill>
                       <a:srgbClr val="F0F4F5"/>
                     </a:solidFill>
                   </a:tcPr>
@@ -6142,7 +6142,7 @@
                           <a:ea typeface="Calibri" pitchFamily="34" charset="-122"/>
                           <a:cs typeface="Calibri" pitchFamily="34" charset="-120"/>
                         </a:rPr>
-                        <a:t>US$ 11,4 mi</a:t>
+                        <a:t>US$ 8,7 mi</a:t>
                       </a:r>
                       <a:endParaRPr lang="en-US" sz="1000" dirty="0">
                         <a:latin typeface="Calibri" charset="0"/>
@@ -7308,280 +7308,6 @@
                           <a:ea typeface="Calibri" pitchFamily="34" charset="-122"/>
                           <a:cs typeface="Calibri" pitchFamily="34" charset="-120"/>
                         </a:rPr>
-                        <a:t>Instalação linha offloading </a:t>
-                      </a:r>
-                      <a:endParaRPr lang="en-US" sz="1000" dirty="0">
-                        <a:latin typeface="Calibri" charset="0"/>
-                        <a:ea typeface="Calibri" charset="0"/>
-                        <a:cs typeface="Calibri" charset="0"/>
-                      </a:endParaRPr>
-                    </a:p>
-                  </a:txBody>
-                  <a:tcPr marL="91440" marR="91440" marT="45720" marB="45720" anchor="ctr">
-                    <a:lnL w="6350" cap="flat" cmpd="sng" algn="ctr">
-                      <a:solidFill>
-                        <a:srgbClr val="E3E8E9"/>
-                      </a:solidFill>
-                      <a:prstDash val="solid"/>
-                      <a:round/>
-                      <a:headEnd type="none" w="med" len="med"/>
-                      <a:tailEnd type="none" w="med" len="med"/>
-                    </a:lnL>
-                    <a:lnR w="6350" cap="flat" cmpd="sng" algn="ctr">
-                      <a:solidFill>
-                        <a:srgbClr val="E3E8E9"/>
-                      </a:solidFill>
-                      <a:prstDash val="solid"/>
-                      <a:round/>
-                      <a:headEnd type="none" w="med" len="med"/>
-                      <a:tailEnd type="none" w="med" len="med"/>
-                    </a:lnR>
-                    <a:lnT w="6350" cap="flat" cmpd="sng" algn="ctr">
-                      <a:solidFill>
-                        <a:srgbClr val="E3E8E9"/>
-                      </a:solidFill>
-                      <a:prstDash val="solid"/>
-                      <a:round/>
-                      <a:headEnd type="none" w="med" len="med"/>
-                      <a:tailEnd type="none" w="med" len="med"/>
-                    </a:lnT>
-                    <a:lnB w="6350" cap="flat" cmpd="sng" algn="ctr">
-                      <a:solidFill>
-                        <a:srgbClr val="E3E8E9"/>
-                      </a:solidFill>
-                      <a:prstDash val="solid"/>
-                      <a:round/>
-                      <a:headEnd type="none" w="med" len="med"/>
-                      <a:tailEnd type="none" w="med" len="med"/>
-                    </a:lnB>
-                    <a:solidFill>
-                      <a:srgbClr val="FFFFFF"/>
-                    </a:solidFill>
-                  </a:tcPr>
-                </a:tc>
-                <a:tc>
-                  <a:txBody>
-                    <a:bodyPr/>
-                    <a:lstStyle/>
-                    <a:p>
-                      <a:pPr indent="0" marL="0">
-                        <a:buNone/>
-                      </a:pPr>
-                      <a:r>
-                        <a:rPr lang="en-US" sz="950" dirty="0">
-                          <a:solidFill>
-                            <a:srgbClr val="5B6B73"/>
-                          </a:solidFill>
-                          <a:latin typeface="Calibri" pitchFamily="34" charset="0"/>
-                          <a:ea typeface="Calibri" pitchFamily="34" charset="-122"/>
-                          <a:cs typeface="Calibri" pitchFamily="34" charset="-120"/>
-                        </a:rPr>
-                        <a:t>Integridade e Regulatório</a:t>
-                      </a:r>
-                      <a:endParaRPr lang="en-US" sz="950" dirty="0">
-                        <a:latin typeface="Calibri" charset="0"/>
-                        <a:ea typeface="Calibri" charset="0"/>
-                        <a:cs typeface="Calibri" charset="0"/>
-                      </a:endParaRPr>
-                    </a:p>
-                  </a:txBody>
-                  <a:tcPr marL="91440" marR="91440" marT="45720" marB="45720" anchor="ctr">
-                    <a:lnL w="6350" cap="flat" cmpd="sng" algn="ctr">
-                      <a:solidFill>
-                        <a:srgbClr val="E3E8E9"/>
-                      </a:solidFill>
-                      <a:prstDash val="solid"/>
-                      <a:round/>
-                      <a:headEnd type="none" w="med" len="med"/>
-                      <a:tailEnd type="none" w="med" len="med"/>
-                    </a:lnL>
-                    <a:lnR w="6350" cap="flat" cmpd="sng" algn="ctr">
-                      <a:solidFill>
-                        <a:srgbClr val="E3E8E9"/>
-                      </a:solidFill>
-                      <a:prstDash val="solid"/>
-                      <a:round/>
-                      <a:headEnd type="none" w="med" len="med"/>
-                      <a:tailEnd type="none" w="med" len="med"/>
-                    </a:lnR>
-                    <a:lnT w="6350" cap="flat" cmpd="sng" algn="ctr">
-                      <a:solidFill>
-                        <a:srgbClr val="E3E8E9"/>
-                      </a:solidFill>
-                      <a:prstDash val="solid"/>
-                      <a:round/>
-                      <a:headEnd type="none" w="med" len="med"/>
-                      <a:tailEnd type="none" w="med" len="med"/>
-                    </a:lnT>
-                    <a:lnB w="6350" cap="flat" cmpd="sng" algn="ctr">
-                      <a:solidFill>
-                        <a:srgbClr val="E3E8E9"/>
-                      </a:solidFill>
-                      <a:prstDash val="solid"/>
-                      <a:round/>
-                      <a:headEnd type="none" w="med" len="med"/>
-                      <a:tailEnd type="none" w="med" len="med"/>
-                    </a:lnB>
-                    <a:solidFill>
-                      <a:srgbClr val="FFFFFF"/>
-                    </a:solidFill>
-                  </a:tcPr>
-                </a:tc>
-                <a:tc>
-                  <a:txBody>
-                    <a:bodyPr/>
-                    <a:lstStyle/>
-                    <a:p>
-                      <a:pPr indent="0" marL="0">
-                        <a:buNone/>
-                      </a:pPr>
-                      <a:r>
-                        <a:rPr lang="en-US" sz="950" dirty="0">
-                          <a:solidFill>
-                            <a:srgbClr val="5B6B73"/>
-                          </a:solidFill>
-                          <a:latin typeface="Calibri" pitchFamily="34" charset="0"/>
-                          <a:ea typeface="Calibri" pitchFamily="34" charset="-122"/>
-                          <a:cs typeface="Calibri" pitchFamily="34" charset="-120"/>
-                        </a:rPr>
-                        <a:t>INT - Integridade</a:t>
-                      </a:r>
-                      <a:endParaRPr lang="en-US" sz="950" dirty="0">
-                        <a:latin typeface="Calibri" charset="0"/>
-                        <a:ea typeface="Calibri" charset="0"/>
-                        <a:cs typeface="Calibri" charset="0"/>
-                      </a:endParaRPr>
-                    </a:p>
-                  </a:txBody>
-                  <a:tcPr marL="91440" marR="91440" marT="45720" marB="45720" anchor="ctr">
-                    <a:lnL w="6350" cap="flat" cmpd="sng" algn="ctr">
-                      <a:solidFill>
-                        <a:srgbClr val="E3E8E9"/>
-                      </a:solidFill>
-                      <a:prstDash val="solid"/>
-                      <a:round/>
-                      <a:headEnd type="none" w="med" len="med"/>
-                      <a:tailEnd type="none" w="med" len="med"/>
-                    </a:lnL>
-                    <a:lnR w="6350" cap="flat" cmpd="sng" algn="ctr">
-                      <a:solidFill>
-                        <a:srgbClr val="E3E8E9"/>
-                      </a:solidFill>
-                      <a:prstDash val="solid"/>
-                      <a:round/>
-                      <a:headEnd type="none" w="med" len="med"/>
-                      <a:tailEnd type="none" w="med" len="med"/>
-                    </a:lnR>
-                    <a:lnT w="6350" cap="flat" cmpd="sng" algn="ctr">
-                      <a:solidFill>
-                        <a:srgbClr val="E3E8E9"/>
-                      </a:solidFill>
-                      <a:prstDash val="solid"/>
-                      <a:round/>
-                      <a:headEnd type="none" w="med" len="med"/>
-                      <a:tailEnd type="none" w="med" len="med"/>
-                    </a:lnT>
-                    <a:lnB w="6350" cap="flat" cmpd="sng" algn="ctr">
-                      <a:solidFill>
-                        <a:srgbClr val="E3E8E9"/>
-                      </a:solidFill>
-                      <a:prstDash val="solid"/>
-                      <a:round/>
-                      <a:headEnd type="none" w="med" len="med"/>
-                      <a:tailEnd type="none" w="med" len="med"/>
-                    </a:lnB>
-                    <a:solidFill>
-                      <a:srgbClr val="FFFFFF"/>
-                    </a:solidFill>
-                  </a:tcPr>
-                </a:tc>
-                <a:tc>
-                  <a:txBody>
-                    <a:bodyPr/>
-                    <a:lstStyle/>
-                    <a:p>
-                      <a:pPr algn="r" indent="0" marL="0">
-                        <a:buNone/>
-                      </a:pPr>
-                      <a:r>
-                        <a:rPr lang="en-US" sz="1000" b="1" dirty="0">
-                          <a:solidFill>
-                            <a:srgbClr val="0B2A3D"/>
-                          </a:solidFill>
-                          <a:latin typeface="Calibri" pitchFamily="34" charset="0"/>
-                          <a:ea typeface="Calibri" pitchFamily="34" charset="-122"/>
-                          <a:cs typeface="Calibri" pitchFamily="34" charset="-120"/>
-                        </a:rPr>
-                        <a:t>US$ 1,7 mi</a:t>
-                      </a:r>
-                      <a:endParaRPr lang="en-US" sz="1000" dirty="0">
-                        <a:latin typeface="Calibri" charset="0"/>
-                        <a:ea typeface="Calibri" charset="0"/>
-                        <a:cs typeface="Calibri" charset="0"/>
-                      </a:endParaRPr>
-                    </a:p>
-                  </a:txBody>
-                  <a:tcPr marL="91440" marR="91440" marT="45720" marB="45720" anchor="ctr">
-                    <a:lnL w="6350" cap="flat" cmpd="sng" algn="ctr">
-                      <a:solidFill>
-                        <a:srgbClr val="E3E8E9"/>
-                      </a:solidFill>
-                      <a:prstDash val="solid"/>
-                      <a:round/>
-                      <a:headEnd type="none" w="med" len="med"/>
-                      <a:tailEnd type="none" w="med" len="med"/>
-                    </a:lnL>
-                    <a:lnR w="6350" cap="flat" cmpd="sng" algn="ctr">
-                      <a:solidFill>
-                        <a:srgbClr val="E3E8E9"/>
-                      </a:solidFill>
-                      <a:prstDash val="solid"/>
-                      <a:round/>
-                      <a:headEnd type="none" w="med" len="med"/>
-                      <a:tailEnd type="none" w="med" len="med"/>
-                    </a:lnR>
-                    <a:lnT w="6350" cap="flat" cmpd="sng" algn="ctr">
-                      <a:solidFill>
-                        <a:srgbClr val="E3E8E9"/>
-                      </a:solidFill>
-                      <a:prstDash val="solid"/>
-                      <a:round/>
-                      <a:headEnd type="none" w="med" len="med"/>
-                      <a:tailEnd type="none" w="med" len="med"/>
-                    </a:lnT>
-                    <a:lnB w="6350" cap="flat" cmpd="sng" algn="ctr">
-                      <a:solidFill>
-                        <a:srgbClr val="E3E8E9"/>
-                      </a:solidFill>
-                      <a:prstDash val="solid"/>
-                      <a:round/>
-                      <a:headEnd type="none" w="med" len="med"/>
-                      <a:tailEnd type="none" w="med" len="med"/>
-                    </a:lnB>
-                    <a:solidFill>
-                      <a:srgbClr val="FFFFFF"/>
-                    </a:solidFill>
-                  </a:tcPr>
-                </a:tc>
-              </a:tr>
-              <a:tr h="288036">
-                <a:tc>
-                  <a:txBody>
-                    <a:bodyPr/>
-                    <a:lstStyle/>
-                    <a:p>
-                      <a:pPr indent="0" marL="0">
-                        <a:buNone/>
-                      </a:pPr>
-                      <a:r>
-                        <a:rPr lang="en-US" sz="1000" dirty="0">
-                          <a:solidFill>
-                            <a:srgbClr val="1C2B33"/>
-                          </a:solidFill>
-                          <a:latin typeface="Calibri" pitchFamily="34" charset="0"/>
-                          <a:ea typeface="Calibri" pitchFamily="34" charset="-122"/>
-                          <a:cs typeface="Calibri" pitchFamily="34" charset="-120"/>
-                        </a:rPr>
                         <a:t>REVAMP IGG</a:t>
                       </a:r>
                       <a:endParaRPr lang="en-US" sz="1000" dirty="0">
@@ -7629,7 +7355,7 @@
                       <a:tailEnd type="none" w="med" len="med"/>
                     </a:lnB>
                     <a:solidFill>
-                      <a:srgbClr val="F0F4F5"/>
+                      <a:srgbClr val="FFFFFF"/>
                     </a:solidFill>
                   </a:tcPr>
                 </a:tc>
@@ -7697,7 +7423,7 @@
                       <a:tailEnd type="none" w="med" len="med"/>
                     </a:lnB>
                     <a:solidFill>
-                      <a:srgbClr val="F0F4F5"/>
+                      <a:srgbClr val="FFFFFF"/>
                     </a:solidFill>
                   </a:tcPr>
                 </a:tc>
@@ -7765,7 +7491,7 @@
                       <a:tailEnd type="none" w="med" len="med"/>
                     </a:lnB>
                     <a:solidFill>
-                      <a:srgbClr val="F0F4F5"/>
+                      <a:srgbClr val="FFFFFF"/>
                     </a:solidFill>
                   </a:tcPr>
                 </a:tc>
@@ -7833,7 +7559,7 @@
                       <a:tailEnd type="none" w="med" len="med"/>
                     </a:lnB>
                     <a:solidFill>
-                      <a:srgbClr val="F0F4F5"/>
+                      <a:srgbClr val="FFFFFF"/>
                     </a:solidFill>
                   </a:tcPr>
                 </a:tc>
@@ -7903,6 +7629,280 @@
                       <a:tailEnd type="none" w="med" len="med"/>
                     </a:lnB>
                     <a:solidFill>
+                      <a:srgbClr val="F0F4F5"/>
+                    </a:solidFill>
+                  </a:tcPr>
+                </a:tc>
+                <a:tc>
+                  <a:txBody>
+                    <a:bodyPr/>
+                    <a:lstStyle/>
+                    <a:p>
+                      <a:pPr indent="0" marL="0">
+                        <a:buNone/>
+                      </a:pPr>
+                      <a:r>
+                        <a:rPr lang="en-US" sz="950" dirty="0">
+                          <a:solidFill>
+                            <a:srgbClr val="5B6B73"/>
+                          </a:solidFill>
+                          <a:latin typeface="Calibri" pitchFamily="34" charset="0"/>
+                          <a:ea typeface="Calibri" pitchFamily="34" charset="-122"/>
+                          <a:cs typeface="Calibri" pitchFamily="34" charset="-120"/>
+                        </a:rPr>
+                        <a:t>Eficiência de Produção</a:t>
+                      </a:r>
+                      <a:endParaRPr lang="en-US" sz="950" dirty="0">
+                        <a:latin typeface="Calibri" charset="0"/>
+                        <a:ea typeface="Calibri" charset="0"/>
+                        <a:cs typeface="Calibri" charset="0"/>
+                      </a:endParaRPr>
+                    </a:p>
+                  </a:txBody>
+                  <a:tcPr marL="91440" marR="91440" marT="45720" marB="45720" anchor="ctr">
+                    <a:lnL w="6350" cap="flat" cmpd="sng" algn="ctr">
+                      <a:solidFill>
+                        <a:srgbClr val="E3E8E9"/>
+                      </a:solidFill>
+                      <a:prstDash val="solid"/>
+                      <a:round/>
+                      <a:headEnd type="none" w="med" len="med"/>
+                      <a:tailEnd type="none" w="med" len="med"/>
+                    </a:lnL>
+                    <a:lnR w="6350" cap="flat" cmpd="sng" algn="ctr">
+                      <a:solidFill>
+                        <a:srgbClr val="E3E8E9"/>
+                      </a:solidFill>
+                      <a:prstDash val="solid"/>
+                      <a:round/>
+                      <a:headEnd type="none" w="med" len="med"/>
+                      <a:tailEnd type="none" w="med" len="med"/>
+                    </a:lnR>
+                    <a:lnT w="6350" cap="flat" cmpd="sng" algn="ctr">
+                      <a:solidFill>
+                        <a:srgbClr val="E3E8E9"/>
+                      </a:solidFill>
+                      <a:prstDash val="solid"/>
+                      <a:round/>
+                      <a:headEnd type="none" w="med" len="med"/>
+                      <a:tailEnd type="none" w="med" len="med"/>
+                    </a:lnT>
+                    <a:lnB w="6350" cap="flat" cmpd="sng" algn="ctr">
+                      <a:solidFill>
+                        <a:srgbClr val="E3E8E9"/>
+                      </a:solidFill>
+                      <a:prstDash val="solid"/>
+                      <a:round/>
+                      <a:headEnd type="none" w="med" len="med"/>
+                      <a:tailEnd type="none" w="med" len="med"/>
+                    </a:lnB>
+                    <a:solidFill>
+                      <a:srgbClr val="F0F4F5"/>
+                    </a:solidFill>
+                  </a:tcPr>
+                </a:tc>
+                <a:tc>
+                  <a:txBody>
+                    <a:bodyPr/>
+                    <a:lstStyle/>
+                    <a:p>
+                      <a:pPr indent="0" marL="0">
+                        <a:buNone/>
+                      </a:pPr>
+                      <a:r>
+                        <a:rPr lang="en-US" sz="950" dirty="0">
+                          <a:solidFill>
+                            <a:srgbClr val="5B6B73"/>
+                          </a:solidFill>
+                          <a:latin typeface="Calibri" pitchFamily="34" charset="0"/>
+                          <a:ea typeface="Calibri" pitchFamily="34" charset="-122"/>
+                          <a:cs typeface="Calibri" pitchFamily="34" charset="-120"/>
+                        </a:rPr>
+                        <a:t>Projetos</a:t>
+                      </a:r>
+                      <a:endParaRPr lang="en-US" sz="950" dirty="0">
+                        <a:latin typeface="Calibri" charset="0"/>
+                        <a:ea typeface="Calibri" charset="0"/>
+                        <a:cs typeface="Calibri" charset="0"/>
+                      </a:endParaRPr>
+                    </a:p>
+                  </a:txBody>
+                  <a:tcPr marL="91440" marR="91440" marT="45720" marB="45720" anchor="ctr">
+                    <a:lnL w="6350" cap="flat" cmpd="sng" algn="ctr">
+                      <a:solidFill>
+                        <a:srgbClr val="E3E8E9"/>
+                      </a:solidFill>
+                      <a:prstDash val="solid"/>
+                      <a:round/>
+                      <a:headEnd type="none" w="med" len="med"/>
+                      <a:tailEnd type="none" w="med" len="med"/>
+                    </a:lnL>
+                    <a:lnR w="6350" cap="flat" cmpd="sng" algn="ctr">
+                      <a:solidFill>
+                        <a:srgbClr val="E3E8E9"/>
+                      </a:solidFill>
+                      <a:prstDash val="solid"/>
+                      <a:round/>
+                      <a:headEnd type="none" w="med" len="med"/>
+                      <a:tailEnd type="none" w="med" len="med"/>
+                    </a:lnR>
+                    <a:lnT w="6350" cap="flat" cmpd="sng" algn="ctr">
+                      <a:solidFill>
+                        <a:srgbClr val="E3E8E9"/>
+                      </a:solidFill>
+                      <a:prstDash val="solid"/>
+                      <a:round/>
+                      <a:headEnd type="none" w="med" len="med"/>
+                      <a:tailEnd type="none" w="med" len="med"/>
+                    </a:lnT>
+                    <a:lnB w="6350" cap="flat" cmpd="sng" algn="ctr">
+                      <a:solidFill>
+                        <a:srgbClr val="E3E8E9"/>
+                      </a:solidFill>
+                      <a:prstDash val="solid"/>
+                      <a:round/>
+                      <a:headEnd type="none" w="med" len="med"/>
+                      <a:tailEnd type="none" w="med" len="med"/>
+                    </a:lnB>
+                    <a:solidFill>
+                      <a:srgbClr val="F0F4F5"/>
+                    </a:solidFill>
+                  </a:tcPr>
+                </a:tc>
+                <a:tc>
+                  <a:txBody>
+                    <a:bodyPr/>
+                    <a:lstStyle/>
+                    <a:p>
+                      <a:pPr algn="r" indent="0" marL="0">
+                        <a:buNone/>
+                      </a:pPr>
+                      <a:r>
+                        <a:rPr lang="en-US" sz="1000" b="1" dirty="0">
+                          <a:solidFill>
+                            <a:srgbClr val="0B2A3D"/>
+                          </a:solidFill>
+                          <a:latin typeface="Calibri" pitchFamily="34" charset="0"/>
+                          <a:ea typeface="Calibri" pitchFamily="34" charset="-122"/>
+                          <a:cs typeface="Calibri" pitchFamily="34" charset="-120"/>
+                        </a:rPr>
+                        <a:t>US$ 1,4 mi</a:t>
+                      </a:r>
+                      <a:endParaRPr lang="en-US" sz="1000" dirty="0">
+                        <a:latin typeface="Calibri" charset="0"/>
+                        <a:ea typeface="Calibri" charset="0"/>
+                        <a:cs typeface="Calibri" charset="0"/>
+                      </a:endParaRPr>
+                    </a:p>
+                  </a:txBody>
+                  <a:tcPr marL="91440" marR="91440" marT="45720" marB="45720" anchor="ctr">
+                    <a:lnL w="6350" cap="flat" cmpd="sng" algn="ctr">
+                      <a:solidFill>
+                        <a:srgbClr val="E3E8E9"/>
+                      </a:solidFill>
+                      <a:prstDash val="solid"/>
+                      <a:round/>
+                      <a:headEnd type="none" w="med" len="med"/>
+                      <a:tailEnd type="none" w="med" len="med"/>
+                    </a:lnL>
+                    <a:lnR w="6350" cap="flat" cmpd="sng" algn="ctr">
+                      <a:solidFill>
+                        <a:srgbClr val="E3E8E9"/>
+                      </a:solidFill>
+                      <a:prstDash val="solid"/>
+                      <a:round/>
+                      <a:headEnd type="none" w="med" len="med"/>
+                      <a:tailEnd type="none" w="med" len="med"/>
+                    </a:lnR>
+                    <a:lnT w="6350" cap="flat" cmpd="sng" algn="ctr">
+                      <a:solidFill>
+                        <a:srgbClr val="E3E8E9"/>
+                      </a:solidFill>
+                      <a:prstDash val="solid"/>
+                      <a:round/>
+                      <a:headEnd type="none" w="med" len="med"/>
+                      <a:tailEnd type="none" w="med" len="med"/>
+                    </a:lnT>
+                    <a:lnB w="6350" cap="flat" cmpd="sng" algn="ctr">
+                      <a:solidFill>
+                        <a:srgbClr val="E3E8E9"/>
+                      </a:solidFill>
+                      <a:prstDash val="solid"/>
+                      <a:round/>
+                      <a:headEnd type="none" w="med" len="med"/>
+                      <a:tailEnd type="none" w="med" len="med"/>
+                    </a:lnB>
+                    <a:solidFill>
+                      <a:srgbClr val="F0F4F5"/>
+                    </a:solidFill>
+                  </a:tcPr>
+                </a:tc>
+              </a:tr>
+              <a:tr h="288036">
+                <a:tc>
+                  <a:txBody>
+                    <a:bodyPr/>
+                    <a:lstStyle/>
+                    <a:p>
+                      <a:pPr indent="0" marL="0">
+                        <a:buNone/>
+                      </a:pPr>
+                      <a:r>
+                        <a:rPr lang="en-US" sz="1000" dirty="0">
+                          <a:solidFill>
+                            <a:srgbClr val="1C2B33"/>
+                          </a:solidFill>
+                          <a:latin typeface="Calibri" pitchFamily="34" charset="0"/>
+                          <a:ea typeface="Calibri" pitchFamily="34" charset="-122"/>
+                          <a:cs typeface="Calibri" pitchFamily="34" charset="-120"/>
+                        </a:rPr>
+                        <a:t>Skids de Dilúvio</a:t>
+                      </a:r>
+                      <a:endParaRPr lang="en-US" sz="1000" dirty="0">
+                        <a:latin typeface="Calibri" charset="0"/>
+                        <a:ea typeface="Calibri" charset="0"/>
+                        <a:cs typeface="Calibri" charset="0"/>
+                      </a:endParaRPr>
+                    </a:p>
+                  </a:txBody>
+                  <a:tcPr marL="91440" marR="91440" marT="45720" marB="45720" anchor="ctr">
+                    <a:lnL w="6350" cap="flat" cmpd="sng" algn="ctr">
+                      <a:solidFill>
+                        <a:srgbClr val="E3E8E9"/>
+                      </a:solidFill>
+                      <a:prstDash val="solid"/>
+                      <a:round/>
+                      <a:headEnd type="none" w="med" len="med"/>
+                      <a:tailEnd type="none" w="med" len="med"/>
+                    </a:lnL>
+                    <a:lnR w="6350" cap="flat" cmpd="sng" algn="ctr">
+                      <a:solidFill>
+                        <a:srgbClr val="E3E8E9"/>
+                      </a:solidFill>
+                      <a:prstDash val="solid"/>
+                      <a:round/>
+                      <a:headEnd type="none" w="med" len="med"/>
+                      <a:tailEnd type="none" w="med" len="med"/>
+                    </a:lnR>
+                    <a:lnT w="6350" cap="flat" cmpd="sng" algn="ctr">
+                      <a:solidFill>
+                        <a:srgbClr val="E3E8E9"/>
+                      </a:solidFill>
+                      <a:prstDash val="solid"/>
+                      <a:round/>
+                      <a:headEnd type="none" w="med" len="med"/>
+                      <a:tailEnd type="none" w="med" len="med"/>
+                    </a:lnT>
+                    <a:lnB w="6350" cap="flat" cmpd="sng" algn="ctr">
+                      <a:solidFill>
+                        <a:srgbClr val="E3E8E9"/>
+                      </a:solidFill>
+                      <a:prstDash val="solid"/>
+                      <a:round/>
+                      <a:headEnd type="none" w="med" len="med"/>
+                      <a:tailEnd type="none" w="med" len="med"/>
+                    </a:lnB>
+                    <a:solidFill>
                       <a:srgbClr val="FFFFFF"/>
                     </a:solidFill>
                   </a:tcPr>
@@ -7924,7 +7924,7 @@
                           <a:ea typeface="Calibri" pitchFamily="34" charset="-122"/>
                           <a:cs typeface="Calibri" pitchFamily="34" charset="-120"/>
                         </a:rPr>
-                        <a:t>Eficiência de Produção</a:t>
+                        <a:t>Bem Estar/Segurança</a:t>
                       </a:r>
                       <a:endParaRPr lang="en-US" sz="950" dirty="0">
                         <a:latin typeface="Calibri" charset="0"/>
@@ -8060,7 +8060,7 @@
                           <a:ea typeface="Calibri" pitchFamily="34" charset="-122"/>
                           <a:cs typeface="Calibri" pitchFamily="34" charset="-120"/>
                         </a:rPr>
-                        <a:t>US$ 1,6 mi</a:t>
+                        <a:t>US$ 1,3 mi</a:t>
                       </a:r>
                       <a:endParaRPr lang="en-US" sz="1000" dirty="0">
                         <a:latin typeface="Calibri" charset="0"/>
@@ -8334,7 +8334,7 @@
                           <a:ea typeface="Calibri" pitchFamily="34" charset="-122"/>
                           <a:cs typeface="Calibri" pitchFamily="34" charset="-120"/>
                         </a:rPr>
-                        <a:t>US$ 1,4 mi</a:t>
+                        <a:t>US$ 1,2 mi</a:t>
                       </a:r>
                       <a:endParaRPr lang="en-US" sz="1000" dirty="0">
                         <a:latin typeface="Calibri" charset="0"/>
@@ -8404,7 +8404,7 @@
                           <a:ea typeface="Calibri" pitchFamily="34" charset="-122"/>
                           <a:cs typeface="Calibri" pitchFamily="34" charset="-120"/>
                         </a:rPr>
-                        <a:t>Skids de Dilúvio</a:t>
+                        <a:t>TROCADOR DE CALOR DO GERADOR - GT4</a:t>
                       </a:r>
                       <a:endParaRPr lang="en-US" sz="1000" dirty="0">
                         <a:latin typeface="Calibri" charset="0"/>
@@ -8472,7 +8472,7 @@
                           <a:ea typeface="Calibri" pitchFamily="34" charset="-122"/>
                           <a:cs typeface="Calibri" pitchFamily="34" charset="-120"/>
                         </a:rPr>
-                        <a:t>Bem Estar/Segurança</a:t>
+                        <a:t>Rotina Operacional</a:t>
                       </a:r>
                       <a:endParaRPr lang="en-US" sz="950" dirty="0">
                         <a:latin typeface="Calibri" charset="0"/>
@@ -8520,6 +8520,280 @@
                     </a:lnB>
                     <a:solidFill>
                       <a:srgbClr val="FFFFFF"/>
+                    </a:solidFill>
+                  </a:tcPr>
+                </a:tc>
+                <a:tc>
+                  <a:txBody>
+                    <a:bodyPr/>
+                    <a:lstStyle/>
+                    <a:p>
+                      <a:pPr indent="0" marL="0">
+                        <a:buNone/>
+                      </a:pPr>
+                      <a:r>
+                        <a:rPr lang="en-US" sz="950" dirty="0">
+                          <a:solidFill>
+                            <a:srgbClr val="5B6B73"/>
+                          </a:solidFill>
+                          <a:latin typeface="Calibri" pitchFamily="34" charset="0"/>
+                          <a:ea typeface="Calibri" pitchFamily="34" charset="-122"/>
+                          <a:cs typeface="Calibri" pitchFamily="34" charset="-120"/>
+                        </a:rPr>
+                        <a:t>MNT – Manutenção</a:t>
+                      </a:r>
+                      <a:endParaRPr lang="en-US" sz="950" dirty="0">
+                        <a:latin typeface="Calibri" charset="0"/>
+                        <a:ea typeface="Calibri" charset="0"/>
+                        <a:cs typeface="Calibri" charset="0"/>
+                      </a:endParaRPr>
+                    </a:p>
+                  </a:txBody>
+                  <a:tcPr marL="91440" marR="91440" marT="45720" marB="45720" anchor="ctr">
+                    <a:lnL w="6350" cap="flat" cmpd="sng" algn="ctr">
+                      <a:solidFill>
+                        <a:srgbClr val="E3E8E9"/>
+                      </a:solidFill>
+                      <a:prstDash val="solid"/>
+                      <a:round/>
+                      <a:headEnd type="none" w="med" len="med"/>
+                      <a:tailEnd type="none" w="med" len="med"/>
+                    </a:lnL>
+                    <a:lnR w="6350" cap="flat" cmpd="sng" algn="ctr">
+                      <a:solidFill>
+                        <a:srgbClr val="E3E8E9"/>
+                      </a:solidFill>
+                      <a:prstDash val="solid"/>
+                      <a:round/>
+                      <a:headEnd type="none" w="med" len="med"/>
+                      <a:tailEnd type="none" w="med" len="med"/>
+                    </a:lnR>
+                    <a:lnT w="6350" cap="flat" cmpd="sng" algn="ctr">
+                      <a:solidFill>
+                        <a:srgbClr val="E3E8E9"/>
+                      </a:solidFill>
+                      <a:prstDash val="solid"/>
+                      <a:round/>
+                      <a:headEnd type="none" w="med" len="med"/>
+                      <a:tailEnd type="none" w="med" len="med"/>
+                    </a:lnT>
+                    <a:lnB w="6350" cap="flat" cmpd="sng" algn="ctr">
+                      <a:solidFill>
+                        <a:srgbClr val="E3E8E9"/>
+                      </a:solidFill>
+                      <a:prstDash val="solid"/>
+                      <a:round/>
+                      <a:headEnd type="none" w="med" len="med"/>
+                      <a:tailEnd type="none" w="med" len="med"/>
+                    </a:lnB>
+                    <a:solidFill>
+                      <a:srgbClr val="FFFFFF"/>
+                    </a:solidFill>
+                  </a:tcPr>
+                </a:tc>
+                <a:tc>
+                  <a:txBody>
+                    <a:bodyPr/>
+                    <a:lstStyle/>
+                    <a:p>
+                      <a:pPr algn="r" indent="0" marL="0">
+                        <a:buNone/>
+                      </a:pPr>
+                      <a:r>
+                        <a:rPr lang="en-US" sz="1000" b="1" dirty="0">
+                          <a:solidFill>
+                            <a:srgbClr val="0B2A3D"/>
+                          </a:solidFill>
+                          <a:latin typeface="Calibri" pitchFamily="34" charset="0"/>
+                          <a:ea typeface="Calibri" pitchFamily="34" charset="-122"/>
+                          <a:cs typeface="Calibri" pitchFamily="34" charset="-120"/>
+                        </a:rPr>
+                        <a:t>US$ 1,1 mi</a:t>
+                      </a:r>
+                      <a:endParaRPr lang="en-US" sz="1000" dirty="0">
+                        <a:latin typeface="Calibri" charset="0"/>
+                        <a:ea typeface="Calibri" charset="0"/>
+                        <a:cs typeface="Calibri" charset="0"/>
+                      </a:endParaRPr>
+                    </a:p>
+                  </a:txBody>
+                  <a:tcPr marL="91440" marR="91440" marT="45720" marB="45720" anchor="ctr">
+                    <a:lnL w="6350" cap="flat" cmpd="sng" algn="ctr">
+                      <a:solidFill>
+                        <a:srgbClr val="E3E8E9"/>
+                      </a:solidFill>
+                      <a:prstDash val="solid"/>
+                      <a:round/>
+                      <a:headEnd type="none" w="med" len="med"/>
+                      <a:tailEnd type="none" w="med" len="med"/>
+                    </a:lnL>
+                    <a:lnR w="6350" cap="flat" cmpd="sng" algn="ctr">
+                      <a:solidFill>
+                        <a:srgbClr val="E3E8E9"/>
+                      </a:solidFill>
+                      <a:prstDash val="solid"/>
+                      <a:round/>
+                      <a:headEnd type="none" w="med" len="med"/>
+                      <a:tailEnd type="none" w="med" len="med"/>
+                    </a:lnR>
+                    <a:lnT w="6350" cap="flat" cmpd="sng" algn="ctr">
+                      <a:solidFill>
+                        <a:srgbClr val="E3E8E9"/>
+                      </a:solidFill>
+                      <a:prstDash val="solid"/>
+                      <a:round/>
+                      <a:headEnd type="none" w="med" len="med"/>
+                      <a:tailEnd type="none" w="med" len="med"/>
+                    </a:lnT>
+                    <a:lnB w="6350" cap="flat" cmpd="sng" algn="ctr">
+                      <a:solidFill>
+                        <a:srgbClr val="E3E8E9"/>
+                      </a:solidFill>
+                      <a:prstDash val="solid"/>
+                      <a:round/>
+                      <a:headEnd type="none" w="med" len="med"/>
+                      <a:tailEnd type="none" w="med" len="med"/>
+                    </a:lnB>
+                    <a:solidFill>
+                      <a:srgbClr val="FFFFFF"/>
+                    </a:solidFill>
+                  </a:tcPr>
+                </a:tc>
+              </a:tr>
+              <a:tr h="288036">
+                <a:tc>
+                  <a:txBody>
+                    <a:bodyPr/>
+                    <a:lstStyle/>
+                    <a:p>
+                      <a:pPr indent="0" marL="0">
+                        <a:buNone/>
+                      </a:pPr>
+                      <a:r>
+                        <a:rPr lang="en-US" sz="1000" dirty="0">
+                          <a:solidFill>
+                            <a:srgbClr val="1C2B33"/>
+                          </a:solidFill>
+                          <a:latin typeface="Calibri" pitchFamily="34" charset="0"/>
+                          <a:ea typeface="Calibri" pitchFamily="34" charset="-122"/>
+                          <a:cs typeface="Calibri" pitchFamily="34" charset="-120"/>
+                        </a:rPr>
+                        <a:t>ESTUDOS DE ENGENHARIA</a:t>
+                      </a:r>
+                      <a:endParaRPr lang="en-US" sz="1000" dirty="0">
+                        <a:latin typeface="Calibri" charset="0"/>
+                        <a:ea typeface="Calibri" charset="0"/>
+                        <a:cs typeface="Calibri" charset="0"/>
+                      </a:endParaRPr>
+                    </a:p>
+                  </a:txBody>
+                  <a:tcPr marL="91440" marR="91440" marT="45720" marB="45720" anchor="ctr">
+                    <a:lnL w="6350" cap="flat" cmpd="sng" algn="ctr">
+                      <a:solidFill>
+                        <a:srgbClr val="E3E8E9"/>
+                      </a:solidFill>
+                      <a:prstDash val="solid"/>
+                      <a:round/>
+                      <a:headEnd type="none" w="med" len="med"/>
+                      <a:tailEnd type="none" w="med" len="med"/>
+                    </a:lnL>
+                    <a:lnR w="6350" cap="flat" cmpd="sng" algn="ctr">
+                      <a:solidFill>
+                        <a:srgbClr val="E3E8E9"/>
+                      </a:solidFill>
+                      <a:prstDash val="solid"/>
+                      <a:round/>
+                      <a:headEnd type="none" w="med" len="med"/>
+                      <a:tailEnd type="none" w="med" len="med"/>
+                    </a:lnR>
+                    <a:lnT w="6350" cap="flat" cmpd="sng" algn="ctr">
+                      <a:solidFill>
+                        <a:srgbClr val="E3E8E9"/>
+                      </a:solidFill>
+                      <a:prstDash val="solid"/>
+                      <a:round/>
+                      <a:headEnd type="none" w="med" len="med"/>
+                      <a:tailEnd type="none" w="med" len="med"/>
+                    </a:lnT>
+                    <a:lnB w="6350" cap="flat" cmpd="sng" algn="ctr">
+                      <a:solidFill>
+                        <a:srgbClr val="E3E8E9"/>
+                      </a:solidFill>
+                      <a:prstDash val="solid"/>
+                      <a:round/>
+                      <a:headEnd type="none" w="med" len="med"/>
+                      <a:tailEnd type="none" w="med" len="med"/>
+                    </a:lnB>
+                    <a:solidFill>
+                      <a:srgbClr val="F0F4F5"/>
+                    </a:solidFill>
+                  </a:tcPr>
+                </a:tc>
+                <a:tc>
+                  <a:txBody>
+                    <a:bodyPr/>
+                    <a:lstStyle/>
+                    <a:p>
+                      <a:pPr indent="0" marL="0">
+                        <a:buNone/>
+                      </a:pPr>
+                      <a:r>
+                        <a:rPr lang="en-US" sz="950" dirty="0">
+                          <a:solidFill>
+                            <a:srgbClr val="5B6B73"/>
+                          </a:solidFill>
+                          <a:latin typeface="Calibri" pitchFamily="34" charset="0"/>
+                          <a:ea typeface="Calibri" pitchFamily="34" charset="-122"/>
+                          <a:cs typeface="Calibri" pitchFamily="34" charset="-120"/>
+                        </a:rPr>
+                        <a:t>Eficiência de Produção</a:t>
+                      </a:r>
+                      <a:endParaRPr lang="en-US" sz="950" dirty="0">
+                        <a:latin typeface="Calibri" charset="0"/>
+                        <a:ea typeface="Calibri" charset="0"/>
+                        <a:cs typeface="Calibri" charset="0"/>
+                      </a:endParaRPr>
+                    </a:p>
+                  </a:txBody>
+                  <a:tcPr marL="91440" marR="91440" marT="45720" marB="45720" anchor="ctr">
+                    <a:lnL w="6350" cap="flat" cmpd="sng" algn="ctr">
+                      <a:solidFill>
+                        <a:srgbClr val="E3E8E9"/>
+                      </a:solidFill>
+                      <a:prstDash val="solid"/>
+                      <a:round/>
+                      <a:headEnd type="none" w="med" len="med"/>
+                      <a:tailEnd type="none" w="med" len="med"/>
+                    </a:lnL>
+                    <a:lnR w="6350" cap="flat" cmpd="sng" algn="ctr">
+                      <a:solidFill>
+                        <a:srgbClr val="E3E8E9"/>
+                      </a:solidFill>
+                      <a:prstDash val="solid"/>
+                      <a:round/>
+                      <a:headEnd type="none" w="med" len="med"/>
+                      <a:tailEnd type="none" w="med" len="med"/>
+                    </a:lnR>
+                    <a:lnT w="6350" cap="flat" cmpd="sng" algn="ctr">
+                      <a:solidFill>
+                        <a:srgbClr val="E3E8E9"/>
+                      </a:solidFill>
+                      <a:prstDash val="solid"/>
+                      <a:round/>
+                      <a:headEnd type="none" w="med" len="med"/>
+                      <a:tailEnd type="none" w="med" len="med"/>
+                    </a:lnT>
+                    <a:lnB w="6350" cap="flat" cmpd="sng" algn="ctr">
+                      <a:solidFill>
+                        <a:srgbClr val="E3E8E9"/>
+                      </a:solidFill>
+                      <a:prstDash val="solid"/>
+                      <a:round/>
+                      <a:headEnd type="none" w="med" len="med"/>
+                      <a:tailEnd type="none" w="med" len="med"/>
+                    </a:lnB>
+                    <a:solidFill>
+                      <a:srgbClr val="F0F4F5"/>
                     </a:solidFill>
                   </a:tcPr>
                 </a:tc>
@@ -8587,280 +8861,6 @@
                       <a:tailEnd type="none" w="med" len="med"/>
                     </a:lnB>
                     <a:solidFill>
-                      <a:srgbClr val="FFFFFF"/>
-                    </a:solidFill>
-                  </a:tcPr>
-                </a:tc>
-                <a:tc>
-                  <a:txBody>
-                    <a:bodyPr/>
-                    <a:lstStyle/>
-                    <a:p>
-                      <a:pPr algn="r" indent="0" marL="0">
-                        <a:buNone/>
-                      </a:pPr>
-                      <a:r>
-                        <a:rPr lang="en-US" sz="1000" b="1" dirty="0">
-                          <a:solidFill>
-                            <a:srgbClr val="0B2A3D"/>
-                          </a:solidFill>
-                          <a:latin typeface="Calibri" pitchFamily="34" charset="0"/>
-                          <a:ea typeface="Calibri" pitchFamily="34" charset="-122"/>
-                          <a:cs typeface="Calibri" pitchFamily="34" charset="-120"/>
-                        </a:rPr>
-                        <a:t>US$ 1,3 mi</a:t>
-                      </a:r>
-                      <a:endParaRPr lang="en-US" sz="1000" dirty="0">
-                        <a:latin typeface="Calibri" charset="0"/>
-                        <a:ea typeface="Calibri" charset="0"/>
-                        <a:cs typeface="Calibri" charset="0"/>
-                      </a:endParaRPr>
-                    </a:p>
-                  </a:txBody>
-                  <a:tcPr marL="91440" marR="91440" marT="45720" marB="45720" anchor="ctr">
-                    <a:lnL w="6350" cap="flat" cmpd="sng" algn="ctr">
-                      <a:solidFill>
-                        <a:srgbClr val="E3E8E9"/>
-                      </a:solidFill>
-                      <a:prstDash val="solid"/>
-                      <a:round/>
-                      <a:headEnd type="none" w="med" len="med"/>
-                      <a:tailEnd type="none" w="med" len="med"/>
-                    </a:lnL>
-                    <a:lnR w="6350" cap="flat" cmpd="sng" algn="ctr">
-                      <a:solidFill>
-                        <a:srgbClr val="E3E8E9"/>
-                      </a:solidFill>
-                      <a:prstDash val="solid"/>
-                      <a:round/>
-                      <a:headEnd type="none" w="med" len="med"/>
-                      <a:tailEnd type="none" w="med" len="med"/>
-                    </a:lnR>
-                    <a:lnT w="6350" cap="flat" cmpd="sng" algn="ctr">
-                      <a:solidFill>
-                        <a:srgbClr val="E3E8E9"/>
-                      </a:solidFill>
-                      <a:prstDash val="solid"/>
-                      <a:round/>
-                      <a:headEnd type="none" w="med" len="med"/>
-                      <a:tailEnd type="none" w="med" len="med"/>
-                    </a:lnT>
-                    <a:lnB w="6350" cap="flat" cmpd="sng" algn="ctr">
-                      <a:solidFill>
-                        <a:srgbClr val="E3E8E9"/>
-                      </a:solidFill>
-                      <a:prstDash val="solid"/>
-                      <a:round/>
-                      <a:headEnd type="none" w="med" len="med"/>
-                      <a:tailEnd type="none" w="med" len="med"/>
-                    </a:lnB>
-                    <a:solidFill>
-                      <a:srgbClr val="FFFFFF"/>
-                    </a:solidFill>
-                  </a:tcPr>
-                </a:tc>
-              </a:tr>
-              <a:tr h="288036">
-                <a:tc>
-                  <a:txBody>
-                    <a:bodyPr/>
-                    <a:lstStyle/>
-                    <a:p>
-                      <a:pPr indent="0" marL="0">
-                        <a:buNone/>
-                      </a:pPr>
-                      <a:r>
-                        <a:rPr lang="en-US" sz="1000" dirty="0">
-                          <a:solidFill>
-                            <a:srgbClr val="1C2B33"/>
-                          </a:solidFill>
-                          <a:latin typeface="Calibri" pitchFamily="34" charset="0"/>
-                          <a:ea typeface="Calibri" pitchFamily="34" charset="-122"/>
-                          <a:cs typeface="Calibri" pitchFamily="34" charset="-120"/>
-                        </a:rPr>
-                        <a:t>Combate a Incêndio - Compra e Instalação de Cabines de Dilúvio</a:t>
-                      </a:r>
-                      <a:endParaRPr lang="en-US" sz="1000" dirty="0">
-                        <a:latin typeface="Calibri" charset="0"/>
-                        <a:ea typeface="Calibri" charset="0"/>
-                        <a:cs typeface="Calibri" charset="0"/>
-                      </a:endParaRPr>
-                    </a:p>
-                  </a:txBody>
-                  <a:tcPr marL="91440" marR="91440" marT="45720" marB="45720" anchor="ctr">
-                    <a:lnL w="6350" cap="flat" cmpd="sng" algn="ctr">
-                      <a:solidFill>
-                        <a:srgbClr val="E3E8E9"/>
-                      </a:solidFill>
-                      <a:prstDash val="solid"/>
-                      <a:round/>
-                      <a:headEnd type="none" w="med" len="med"/>
-                      <a:tailEnd type="none" w="med" len="med"/>
-                    </a:lnL>
-                    <a:lnR w="6350" cap="flat" cmpd="sng" algn="ctr">
-                      <a:solidFill>
-                        <a:srgbClr val="E3E8E9"/>
-                      </a:solidFill>
-                      <a:prstDash val="solid"/>
-                      <a:round/>
-                      <a:headEnd type="none" w="med" len="med"/>
-                      <a:tailEnd type="none" w="med" len="med"/>
-                    </a:lnR>
-                    <a:lnT w="6350" cap="flat" cmpd="sng" algn="ctr">
-                      <a:solidFill>
-                        <a:srgbClr val="E3E8E9"/>
-                      </a:solidFill>
-                      <a:prstDash val="solid"/>
-                      <a:round/>
-                      <a:headEnd type="none" w="med" len="med"/>
-                      <a:tailEnd type="none" w="med" len="med"/>
-                    </a:lnT>
-                    <a:lnB w="6350" cap="flat" cmpd="sng" algn="ctr">
-                      <a:solidFill>
-                        <a:srgbClr val="E3E8E9"/>
-                      </a:solidFill>
-                      <a:prstDash val="solid"/>
-                      <a:round/>
-                      <a:headEnd type="none" w="med" len="med"/>
-                      <a:tailEnd type="none" w="med" len="med"/>
-                    </a:lnB>
-                    <a:solidFill>
-                      <a:srgbClr val="F0F4F5"/>
-                    </a:solidFill>
-                  </a:tcPr>
-                </a:tc>
-                <a:tc>
-                  <a:txBody>
-                    <a:bodyPr/>
-                    <a:lstStyle/>
-                    <a:p>
-                      <a:pPr indent="0" marL="0">
-                        <a:buNone/>
-                      </a:pPr>
-                      <a:r>
-                        <a:rPr lang="en-US" sz="950" dirty="0">
-                          <a:solidFill>
-                            <a:srgbClr val="5B6B73"/>
-                          </a:solidFill>
-                          <a:latin typeface="Calibri" pitchFamily="34" charset="0"/>
-                          <a:ea typeface="Calibri" pitchFamily="34" charset="-122"/>
-                          <a:cs typeface="Calibri" pitchFamily="34" charset="-120"/>
-                        </a:rPr>
-                        <a:t>Bem Estar/Segurança</a:t>
-                      </a:r>
-                      <a:endParaRPr lang="en-US" sz="950" dirty="0">
-                        <a:latin typeface="Calibri" charset="0"/>
-                        <a:ea typeface="Calibri" charset="0"/>
-                        <a:cs typeface="Calibri" charset="0"/>
-                      </a:endParaRPr>
-                    </a:p>
-                  </a:txBody>
-                  <a:tcPr marL="91440" marR="91440" marT="45720" marB="45720" anchor="ctr">
-                    <a:lnL w="6350" cap="flat" cmpd="sng" algn="ctr">
-                      <a:solidFill>
-                        <a:srgbClr val="E3E8E9"/>
-                      </a:solidFill>
-                      <a:prstDash val="solid"/>
-                      <a:round/>
-                      <a:headEnd type="none" w="med" len="med"/>
-                      <a:tailEnd type="none" w="med" len="med"/>
-                    </a:lnL>
-                    <a:lnR w="6350" cap="flat" cmpd="sng" algn="ctr">
-                      <a:solidFill>
-                        <a:srgbClr val="E3E8E9"/>
-                      </a:solidFill>
-                      <a:prstDash val="solid"/>
-                      <a:round/>
-                      <a:headEnd type="none" w="med" len="med"/>
-                      <a:tailEnd type="none" w="med" len="med"/>
-                    </a:lnR>
-                    <a:lnT w="6350" cap="flat" cmpd="sng" algn="ctr">
-                      <a:solidFill>
-                        <a:srgbClr val="E3E8E9"/>
-                      </a:solidFill>
-                      <a:prstDash val="solid"/>
-                      <a:round/>
-                      <a:headEnd type="none" w="med" len="med"/>
-                      <a:tailEnd type="none" w="med" len="med"/>
-                    </a:lnT>
-                    <a:lnB w="6350" cap="flat" cmpd="sng" algn="ctr">
-                      <a:solidFill>
-                        <a:srgbClr val="E3E8E9"/>
-                      </a:solidFill>
-                      <a:prstDash val="solid"/>
-                      <a:round/>
-                      <a:headEnd type="none" w="med" len="med"/>
-                      <a:tailEnd type="none" w="med" len="med"/>
-                    </a:lnB>
-                    <a:solidFill>
-                      <a:srgbClr val="F0F4F5"/>
-                    </a:solidFill>
-                  </a:tcPr>
-                </a:tc>
-                <a:tc>
-                  <a:txBody>
-                    <a:bodyPr/>
-                    <a:lstStyle/>
-                    <a:p>
-                      <a:pPr indent="0" marL="0">
-                        <a:buNone/>
-                      </a:pPr>
-                      <a:r>
-                        <a:rPr lang="en-US" sz="950" dirty="0">
-                          <a:solidFill>
-                            <a:srgbClr val="5B6B73"/>
-                          </a:solidFill>
-                          <a:latin typeface="Calibri" pitchFamily="34" charset="0"/>
-                          <a:ea typeface="Calibri" pitchFamily="34" charset="-122"/>
-                          <a:cs typeface="Calibri" pitchFamily="34" charset="-120"/>
-                        </a:rPr>
-                        <a:t>Saúde e Segurança Ocupacional</a:t>
-                      </a:r>
-                      <a:endParaRPr lang="en-US" sz="950" dirty="0">
-                        <a:latin typeface="Calibri" charset="0"/>
-                        <a:ea typeface="Calibri" charset="0"/>
-                        <a:cs typeface="Calibri" charset="0"/>
-                      </a:endParaRPr>
-                    </a:p>
-                  </a:txBody>
-                  <a:tcPr marL="91440" marR="91440" marT="45720" marB="45720" anchor="ctr">
-                    <a:lnL w="6350" cap="flat" cmpd="sng" algn="ctr">
-                      <a:solidFill>
-                        <a:srgbClr val="E3E8E9"/>
-                      </a:solidFill>
-                      <a:prstDash val="solid"/>
-                      <a:round/>
-                      <a:headEnd type="none" w="med" len="med"/>
-                      <a:tailEnd type="none" w="med" len="med"/>
-                    </a:lnL>
-                    <a:lnR w="6350" cap="flat" cmpd="sng" algn="ctr">
-                      <a:solidFill>
-                        <a:srgbClr val="E3E8E9"/>
-                      </a:solidFill>
-                      <a:prstDash val="solid"/>
-                      <a:round/>
-                      <a:headEnd type="none" w="med" len="med"/>
-                      <a:tailEnd type="none" w="med" len="med"/>
-                    </a:lnR>
-                    <a:lnT w="6350" cap="flat" cmpd="sng" algn="ctr">
-                      <a:solidFill>
-                        <a:srgbClr val="E3E8E9"/>
-                      </a:solidFill>
-                      <a:prstDash val="solid"/>
-                      <a:round/>
-                      <a:headEnd type="none" w="med" len="med"/>
-                      <a:tailEnd type="none" w="med" len="med"/>
-                    </a:lnT>
-                    <a:lnB w="6350" cap="flat" cmpd="sng" algn="ctr">
-                      <a:solidFill>
-                        <a:srgbClr val="E3E8E9"/>
-                      </a:solidFill>
-                      <a:prstDash val="solid"/>
-                      <a:round/>
-                      <a:headEnd type="none" w="med" len="med"/>
-                      <a:tailEnd type="none" w="med" len="med"/>
-                    </a:lnB>
-                    <a:solidFill>
                       <a:srgbClr val="F0F4F5"/>
                     </a:solidFill>
                   </a:tcPr>
@@ -8882,7 +8882,7 @@
                           <a:ea typeface="Calibri" pitchFamily="34" charset="-122"/>
                           <a:cs typeface="Calibri" pitchFamily="34" charset="-120"/>
                         </a:rPr>
-                        <a:t>US$ 1,1 mi</a:t>
+                        <a:t>US$ 861,0 mil</a:t>
                       </a:r>
                       <a:endParaRPr lang="en-US" sz="1000" dirty="0">
                         <a:latin typeface="Calibri" charset="0"/>
@@ -8952,7 +8952,7 @@
                           <a:ea typeface="Calibri" pitchFamily="34" charset="-122"/>
                           <a:cs typeface="Calibri" pitchFamily="34" charset="-120"/>
                         </a:rPr>
-                        <a:t>Outros 77 escopos (itens de menor valor individual)</a:t>
+                        <a:t>Outros 44 escopos (itens de menor valor individual)</a:t>
                       </a:r>
                       <a:endParaRPr lang="en-US" sz="950" dirty="0">
                         <a:latin typeface="Calibri" charset="0"/>
@@ -9026,7 +9026,7 @@
                           <a:ea typeface="Calibri" pitchFamily="34" charset="-122"/>
                           <a:cs typeface="Calibri" pitchFamily="34" charset="-120"/>
                         </a:rPr>
-                        <a:t>US$ 17,9 mi</a:t>
+                        <a:t>US$ 6,5 mi</a:t>
                       </a:r>
                       <a:endParaRPr lang="en-US" sz="1000" dirty="0">
                         <a:latin typeface="Calibri" charset="0"/>
@@ -9603,554 +9603,6 @@
                           <a:ea typeface="Calibri" pitchFamily="34" charset="-122"/>
                           <a:cs typeface="Calibri" pitchFamily="34" charset="-120"/>
                         </a:rPr>
-                        <a:t>TROCADOR DE CALOR DO GERADOR - GT4</a:t>
-                      </a:r>
-                      <a:endParaRPr lang="en-US" sz="1000" dirty="0">
-                        <a:latin typeface="Calibri" charset="0"/>
-                        <a:ea typeface="Calibri" charset="0"/>
-                        <a:cs typeface="Calibri" charset="0"/>
-                      </a:endParaRPr>
-                    </a:p>
-                  </a:txBody>
-                  <a:tcPr marL="91440" marR="91440" marT="45720" marB="45720" anchor="ctr">
-                    <a:lnL w="6350" cap="flat" cmpd="sng" algn="ctr">
-                      <a:solidFill>
-                        <a:srgbClr val="E3E8E9"/>
-                      </a:solidFill>
-                      <a:prstDash val="solid"/>
-                      <a:round/>
-                      <a:headEnd type="none" w="med" len="med"/>
-                      <a:tailEnd type="none" w="med" len="med"/>
-                    </a:lnL>
-                    <a:lnR w="6350" cap="flat" cmpd="sng" algn="ctr">
-                      <a:solidFill>
-                        <a:srgbClr val="E3E8E9"/>
-                      </a:solidFill>
-                      <a:prstDash val="solid"/>
-                      <a:round/>
-                      <a:headEnd type="none" w="med" len="med"/>
-                      <a:tailEnd type="none" w="med" len="med"/>
-                    </a:lnR>
-                    <a:lnT w="6350" cap="flat" cmpd="sng" algn="ctr">
-                      <a:solidFill>
-                        <a:srgbClr val="E3E8E9"/>
-                      </a:solidFill>
-                      <a:prstDash val="solid"/>
-                      <a:round/>
-                      <a:headEnd type="none" w="med" len="med"/>
-                      <a:tailEnd type="none" w="med" len="med"/>
-                    </a:lnT>
-                    <a:lnB w="6350" cap="flat" cmpd="sng" algn="ctr">
-                      <a:solidFill>
-                        <a:srgbClr val="E3E8E9"/>
-                      </a:solidFill>
-                      <a:prstDash val="solid"/>
-                      <a:round/>
-                      <a:headEnd type="none" w="med" len="med"/>
-                      <a:tailEnd type="none" w="med" len="med"/>
-                    </a:lnB>
-                    <a:solidFill>
-                      <a:srgbClr val="FFFFFF"/>
-                    </a:solidFill>
-                  </a:tcPr>
-                </a:tc>
-                <a:tc>
-                  <a:txBody>
-                    <a:bodyPr/>
-                    <a:lstStyle/>
-                    <a:p>
-                      <a:pPr indent="0" marL="0">
-                        <a:buNone/>
-                      </a:pPr>
-                      <a:r>
-                        <a:rPr lang="en-US" sz="950" dirty="0">
-                          <a:solidFill>
-                            <a:srgbClr val="5B6B73"/>
-                          </a:solidFill>
-                          <a:latin typeface="Calibri" pitchFamily="34" charset="0"/>
-                          <a:ea typeface="Calibri" pitchFamily="34" charset="-122"/>
-                          <a:cs typeface="Calibri" pitchFamily="34" charset="-120"/>
-                        </a:rPr>
-                        <a:t>Rotina Operacional</a:t>
-                      </a:r>
-                      <a:endParaRPr lang="en-US" sz="950" dirty="0">
-                        <a:latin typeface="Calibri" charset="0"/>
-                        <a:ea typeface="Calibri" charset="0"/>
-                        <a:cs typeface="Calibri" charset="0"/>
-                      </a:endParaRPr>
-                    </a:p>
-                  </a:txBody>
-                  <a:tcPr marL="91440" marR="91440" marT="45720" marB="45720" anchor="ctr">
-                    <a:lnL w="6350" cap="flat" cmpd="sng" algn="ctr">
-                      <a:solidFill>
-                        <a:srgbClr val="E3E8E9"/>
-                      </a:solidFill>
-                      <a:prstDash val="solid"/>
-                      <a:round/>
-                      <a:headEnd type="none" w="med" len="med"/>
-                      <a:tailEnd type="none" w="med" len="med"/>
-                    </a:lnL>
-                    <a:lnR w="6350" cap="flat" cmpd="sng" algn="ctr">
-                      <a:solidFill>
-                        <a:srgbClr val="E3E8E9"/>
-                      </a:solidFill>
-                      <a:prstDash val="solid"/>
-                      <a:round/>
-                      <a:headEnd type="none" w="med" len="med"/>
-                      <a:tailEnd type="none" w="med" len="med"/>
-                    </a:lnR>
-                    <a:lnT w="6350" cap="flat" cmpd="sng" algn="ctr">
-                      <a:solidFill>
-                        <a:srgbClr val="E3E8E9"/>
-                      </a:solidFill>
-                      <a:prstDash val="solid"/>
-                      <a:round/>
-                      <a:headEnd type="none" w="med" len="med"/>
-                      <a:tailEnd type="none" w="med" len="med"/>
-                    </a:lnT>
-                    <a:lnB w="6350" cap="flat" cmpd="sng" algn="ctr">
-                      <a:solidFill>
-                        <a:srgbClr val="E3E8E9"/>
-                      </a:solidFill>
-                      <a:prstDash val="solid"/>
-                      <a:round/>
-                      <a:headEnd type="none" w="med" len="med"/>
-                      <a:tailEnd type="none" w="med" len="med"/>
-                    </a:lnB>
-                    <a:solidFill>
-                      <a:srgbClr val="FFFFFF"/>
-                    </a:solidFill>
-                  </a:tcPr>
-                </a:tc>
-                <a:tc>
-                  <a:txBody>
-                    <a:bodyPr/>
-                    <a:lstStyle/>
-                    <a:p>
-                      <a:pPr indent="0" marL="0">
-                        <a:buNone/>
-                      </a:pPr>
-                      <a:r>
-                        <a:rPr lang="en-US" sz="950" dirty="0">
-                          <a:solidFill>
-                            <a:srgbClr val="5B6B73"/>
-                          </a:solidFill>
-                          <a:latin typeface="Calibri" pitchFamily="34" charset="0"/>
-                          <a:ea typeface="Calibri" pitchFamily="34" charset="-122"/>
-                          <a:cs typeface="Calibri" pitchFamily="34" charset="-120"/>
-                        </a:rPr>
-                        <a:t>MNT – Manutenção</a:t>
-                      </a:r>
-                      <a:endParaRPr lang="en-US" sz="950" dirty="0">
-                        <a:latin typeface="Calibri" charset="0"/>
-                        <a:ea typeface="Calibri" charset="0"/>
-                        <a:cs typeface="Calibri" charset="0"/>
-                      </a:endParaRPr>
-                    </a:p>
-                  </a:txBody>
-                  <a:tcPr marL="91440" marR="91440" marT="45720" marB="45720" anchor="ctr">
-                    <a:lnL w="6350" cap="flat" cmpd="sng" algn="ctr">
-                      <a:solidFill>
-                        <a:srgbClr val="E3E8E9"/>
-                      </a:solidFill>
-                      <a:prstDash val="solid"/>
-                      <a:round/>
-                      <a:headEnd type="none" w="med" len="med"/>
-                      <a:tailEnd type="none" w="med" len="med"/>
-                    </a:lnL>
-                    <a:lnR w="6350" cap="flat" cmpd="sng" algn="ctr">
-                      <a:solidFill>
-                        <a:srgbClr val="E3E8E9"/>
-                      </a:solidFill>
-                      <a:prstDash val="solid"/>
-                      <a:round/>
-                      <a:headEnd type="none" w="med" len="med"/>
-                      <a:tailEnd type="none" w="med" len="med"/>
-                    </a:lnR>
-                    <a:lnT w="6350" cap="flat" cmpd="sng" algn="ctr">
-                      <a:solidFill>
-                        <a:srgbClr val="E3E8E9"/>
-                      </a:solidFill>
-                      <a:prstDash val="solid"/>
-                      <a:round/>
-                      <a:headEnd type="none" w="med" len="med"/>
-                      <a:tailEnd type="none" w="med" len="med"/>
-                    </a:lnT>
-                    <a:lnB w="6350" cap="flat" cmpd="sng" algn="ctr">
-                      <a:solidFill>
-                        <a:srgbClr val="E3E8E9"/>
-                      </a:solidFill>
-                      <a:prstDash val="solid"/>
-                      <a:round/>
-                      <a:headEnd type="none" w="med" len="med"/>
-                      <a:tailEnd type="none" w="med" len="med"/>
-                    </a:lnB>
-                    <a:solidFill>
-                      <a:srgbClr val="FFFFFF"/>
-                    </a:solidFill>
-                  </a:tcPr>
-                </a:tc>
-                <a:tc>
-                  <a:txBody>
-                    <a:bodyPr/>
-                    <a:lstStyle/>
-                    <a:p>
-                      <a:pPr algn="r" indent="0" marL="0">
-                        <a:buNone/>
-                      </a:pPr>
-                      <a:r>
-                        <a:rPr lang="en-US" sz="1000" b="1" dirty="0">
-                          <a:solidFill>
-                            <a:srgbClr val="0B2A3D"/>
-                          </a:solidFill>
-                          <a:latin typeface="Calibri" pitchFamily="34" charset="0"/>
-                          <a:ea typeface="Calibri" pitchFamily="34" charset="-122"/>
-                          <a:cs typeface="Calibri" pitchFamily="34" charset="-120"/>
-                        </a:rPr>
-                        <a:t>US$ 1,1 mi</a:t>
-                      </a:r>
-                      <a:endParaRPr lang="en-US" sz="1000" dirty="0">
-                        <a:latin typeface="Calibri" charset="0"/>
-                        <a:ea typeface="Calibri" charset="0"/>
-                        <a:cs typeface="Calibri" charset="0"/>
-                      </a:endParaRPr>
-                    </a:p>
-                  </a:txBody>
-                  <a:tcPr marL="91440" marR="91440" marT="45720" marB="45720" anchor="ctr">
-                    <a:lnL w="6350" cap="flat" cmpd="sng" algn="ctr">
-                      <a:solidFill>
-                        <a:srgbClr val="E3E8E9"/>
-                      </a:solidFill>
-                      <a:prstDash val="solid"/>
-                      <a:round/>
-                      <a:headEnd type="none" w="med" len="med"/>
-                      <a:tailEnd type="none" w="med" len="med"/>
-                    </a:lnL>
-                    <a:lnR w="6350" cap="flat" cmpd="sng" algn="ctr">
-                      <a:solidFill>
-                        <a:srgbClr val="E3E8E9"/>
-                      </a:solidFill>
-                      <a:prstDash val="solid"/>
-                      <a:round/>
-                      <a:headEnd type="none" w="med" len="med"/>
-                      <a:tailEnd type="none" w="med" len="med"/>
-                    </a:lnR>
-                    <a:lnT w="6350" cap="flat" cmpd="sng" algn="ctr">
-                      <a:solidFill>
-                        <a:srgbClr val="E3E8E9"/>
-                      </a:solidFill>
-                      <a:prstDash val="solid"/>
-                      <a:round/>
-                      <a:headEnd type="none" w="med" len="med"/>
-                      <a:tailEnd type="none" w="med" len="med"/>
-                    </a:lnT>
-                    <a:lnB w="6350" cap="flat" cmpd="sng" algn="ctr">
-                      <a:solidFill>
-                        <a:srgbClr val="E3E8E9"/>
-                      </a:solidFill>
-                      <a:prstDash val="solid"/>
-                      <a:round/>
-                      <a:headEnd type="none" w="med" len="med"/>
-                      <a:tailEnd type="none" w="med" len="med"/>
-                    </a:lnB>
-                    <a:solidFill>
-                      <a:srgbClr val="FFFFFF"/>
-                    </a:solidFill>
-                  </a:tcPr>
-                </a:tc>
-              </a:tr>
-              <a:tr h="288036">
-                <a:tc>
-                  <a:txBody>
-                    <a:bodyPr/>
-                    <a:lstStyle/>
-                    <a:p>
-                      <a:pPr indent="0" marL="0">
-                        <a:buNone/>
-                      </a:pPr>
-                      <a:r>
-                        <a:rPr lang="en-US" sz="1000" dirty="0">
-                          <a:solidFill>
-                            <a:srgbClr val="1C2B33"/>
-                          </a:solidFill>
-                          <a:latin typeface="Calibri" pitchFamily="34" charset="0"/>
-                          <a:ea typeface="Calibri" pitchFamily="34" charset="-122"/>
-                          <a:cs typeface="Calibri" pitchFamily="34" charset="-120"/>
-                        </a:rPr>
-                        <a:t>RO</a:t>
-                      </a:r>
-                      <a:endParaRPr lang="en-US" sz="1000" dirty="0">
-                        <a:latin typeface="Calibri" charset="0"/>
-                        <a:ea typeface="Calibri" charset="0"/>
-                        <a:cs typeface="Calibri" charset="0"/>
-                      </a:endParaRPr>
-                    </a:p>
-                  </a:txBody>
-                  <a:tcPr marL="91440" marR="91440" marT="45720" marB="45720" anchor="ctr">
-                    <a:lnL w="6350" cap="flat" cmpd="sng" algn="ctr">
-                      <a:solidFill>
-                        <a:srgbClr val="E3E8E9"/>
-                      </a:solidFill>
-                      <a:prstDash val="solid"/>
-                      <a:round/>
-                      <a:headEnd type="none" w="med" len="med"/>
-                      <a:tailEnd type="none" w="med" len="med"/>
-                    </a:lnL>
-                    <a:lnR w="6350" cap="flat" cmpd="sng" algn="ctr">
-                      <a:solidFill>
-                        <a:srgbClr val="E3E8E9"/>
-                      </a:solidFill>
-                      <a:prstDash val="solid"/>
-                      <a:round/>
-                      <a:headEnd type="none" w="med" len="med"/>
-                      <a:tailEnd type="none" w="med" len="med"/>
-                    </a:lnR>
-                    <a:lnT w="6350" cap="flat" cmpd="sng" algn="ctr">
-                      <a:solidFill>
-                        <a:srgbClr val="E3E8E9"/>
-                      </a:solidFill>
-                      <a:prstDash val="solid"/>
-                      <a:round/>
-                      <a:headEnd type="none" w="med" len="med"/>
-                      <a:tailEnd type="none" w="med" len="med"/>
-                    </a:lnT>
-                    <a:lnB w="6350" cap="flat" cmpd="sng" algn="ctr">
-                      <a:solidFill>
-                        <a:srgbClr val="E3E8E9"/>
-                      </a:solidFill>
-                      <a:prstDash val="solid"/>
-                      <a:round/>
-                      <a:headEnd type="none" w="med" len="med"/>
-                      <a:tailEnd type="none" w="med" len="med"/>
-                    </a:lnB>
-                    <a:solidFill>
-                      <a:srgbClr val="F0F4F5"/>
-                    </a:solidFill>
-                  </a:tcPr>
-                </a:tc>
-                <a:tc>
-                  <a:txBody>
-                    <a:bodyPr/>
-                    <a:lstStyle/>
-                    <a:p>
-                      <a:pPr indent="0" marL="0">
-                        <a:buNone/>
-                      </a:pPr>
-                      <a:r>
-                        <a:rPr lang="en-US" sz="950" dirty="0">
-                          <a:solidFill>
-                            <a:srgbClr val="5B6B73"/>
-                          </a:solidFill>
-                          <a:latin typeface="Calibri" pitchFamily="34" charset="0"/>
-                          <a:ea typeface="Calibri" pitchFamily="34" charset="-122"/>
-                          <a:cs typeface="Calibri" pitchFamily="34" charset="-120"/>
-                        </a:rPr>
-                        <a:t>Bem Estar/Segurança</a:t>
-                      </a:r>
-                      <a:endParaRPr lang="en-US" sz="950" dirty="0">
-                        <a:latin typeface="Calibri" charset="0"/>
-                        <a:ea typeface="Calibri" charset="0"/>
-                        <a:cs typeface="Calibri" charset="0"/>
-                      </a:endParaRPr>
-                    </a:p>
-                  </a:txBody>
-                  <a:tcPr marL="91440" marR="91440" marT="45720" marB="45720" anchor="ctr">
-                    <a:lnL w="6350" cap="flat" cmpd="sng" algn="ctr">
-                      <a:solidFill>
-                        <a:srgbClr val="E3E8E9"/>
-                      </a:solidFill>
-                      <a:prstDash val="solid"/>
-                      <a:round/>
-                      <a:headEnd type="none" w="med" len="med"/>
-                      <a:tailEnd type="none" w="med" len="med"/>
-                    </a:lnL>
-                    <a:lnR w="6350" cap="flat" cmpd="sng" algn="ctr">
-                      <a:solidFill>
-                        <a:srgbClr val="E3E8E9"/>
-                      </a:solidFill>
-                      <a:prstDash val="solid"/>
-                      <a:round/>
-                      <a:headEnd type="none" w="med" len="med"/>
-                      <a:tailEnd type="none" w="med" len="med"/>
-                    </a:lnR>
-                    <a:lnT w="6350" cap="flat" cmpd="sng" algn="ctr">
-                      <a:solidFill>
-                        <a:srgbClr val="E3E8E9"/>
-                      </a:solidFill>
-                      <a:prstDash val="solid"/>
-                      <a:round/>
-                      <a:headEnd type="none" w="med" len="med"/>
-                      <a:tailEnd type="none" w="med" len="med"/>
-                    </a:lnT>
-                    <a:lnB w="6350" cap="flat" cmpd="sng" algn="ctr">
-                      <a:solidFill>
-                        <a:srgbClr val="E3E8E9"/>
-                      </a:solidFill>
-                      <a:prstDash val="solid"/>
-                      <a:round/>
-                      <a:headEnd type="none" w="med" len="med"/>
-                      <a:tailEnd type="none" w="med" len="med"/>
-                    </a:lnB>
-                    <a:solidFill>
-                      <a:srgbClr val="F0F4F5"/>
-                    </a:solidFill>
-                  </a:tcPr>
-                </a:tc>
-                <a:tc>
-                  <a:txBody>
-                    <a:bodyPr/>
-                    <a:lstStyle/>
-                    <a:p>
-                      <a:pPr indent="0" marL="0">
-                        <a:buNone/>
-                      </a:pPr>
-                      <a:r>
-                        <a:rPr lang="en-US" sz="950" dirty="0">
-                          <a:solidFill>
-                            <a:srgbClr val="5B6B73"/>
-                          </a:solidFill>
-                          <a:latin typeface="Calibri" pitchFamily="34" charset="0"/>
-                          <a:ea typeface="Calibri" pitchFamily="34" charset="-122"/>
-                          <a:cs typeface="Calibri" pitchFamily="34" charset="-120"/>
-                        </a:rPr>
-                        <a:t>Projetos</a:t>
-                      </a:r>
-                      <a:endParaRPr lang="en-US" sz="950" dirty="0">
-                        <a:latin typeface="Calibri" charset="0"/>
-                        <a:ea typeface="Calibri" charset="0"/>
-                        <a:cs typeface="Calibri" charset="0"/>
-                      </a:endParaRPr>
-                    </a:p>
-                  </a:txBody>
-                  <a:tcPr marL="91440" marR="91440" marT="45720" marB="45720" anchor="ctr">
-                    <a:lnL w="6350" cap="flat" cmpd="sng" algn="ctr">
-                      <a:solidFill>
-                        <a:srgbClr val="E3E8E9"/>
-                      </a:solidFill>
-                      <a:prstDash val="solid"/>
-                      <a:round/>
-                      <a:headEnd type="none" w="med" len="med"/>
-                      <a:tailEnd type="none" w="med" len="med"/>
-                    </a:lnL>
-                    <a:lnR w="6350" cap="flat" cmpd="sng" algn="ctr">
-                      <a:solidFill>
-                        <a:srgbClr val="E3E8E9"/>
-                      </a:solidFill>
-                      <a:prstDash val="solid"/>
-                      <a:round/>
-                      <a:headEnd type="none" w="med" len="med"/>
-                      <a:tailEnd type="none" w="med" len="med"/>
-                    </a:lnR>
-                    <a:lnT w="6350" cap="flat" cmpd="sng" algn="ctr">
-                      <a:solidFill>
-                        <a:srgbClr val="E3E8E9"/>
-                      </a:solidFill>
-                      <a:prstDash val="solid"/>
-                      <a:round/>
-                      <a:headEnd type="none" w="med" len="med"/>
-                      <a:tailEnd type="none" w="med" len="med"/>
-                    </a:lnT>
-                    <a:lnB w="6350" cap="flat" cmpd="sng" algn="ctr">
-                      <a:solidFill>
-                        <a:srgbClr val="E3E8E9"/>
-                      </a:solidFill>
-                      <a:prstDash val="solid"/>
-                      <a:round/>
-                      <a:headEnd type="none" w="med" len="med"/>
-                      <a:tailEnd type="none" w="med" len="med"/>
-                    </a:lnB>
-                    <a:solidFill>
-                      <a:srgbClr val="F0F4F5"/>
-                    </a:solidFill>
-                  </a:tcPr>
-                </a:tc>
-                <a:tc>
-                  <a:txBody>
-                    <a:bodyPr/>
-                    <a:lstStyle/>
-                    <a:p>
-                      <a:pPr algn="r" indent="0" marL="0">
-                        <a:buNone/>
-                      </a:pPr>
-                      <a:r>
-                        <a:rPr lang="en-US" sz="1000" b="1" dirty="0">
-                          <a:solidFill>
-                            <a:srgbClr val="0B2A3D"/>
-                          </a:solidFill>
-                          <a:latin typeface="Calibri" pitchFamily="34" charset="0"/>
-                          <a:ea typeface="Calibri" pitchFamily="34" charset="-122"/>
-                          <a:cs typeface="Calibri" pitchFamily="34" charset="-120"/>
-                        </a:rPr>
-                        <a:t>US$ 876,9 mil</a:t>
-                      </a:r>
-                      <a:endParaRPr lang="en-US" sz="1000" dirty="0">
-                        <a:latin typeface="Calibri" charset="0"/>
-                        <a:ea typeface="Calibri" charset="0"/>
-                        <a:cs typeface="Calibri" charset="0"/>
-                      </a:endParaRPr>
-                    </a:p>
-                  </a:txBody>
-                  <a:tcPr marL="91440" marR="91440" marT="45720" marB="45720" anchor="ctr">
-                    <a:lnL w="6350" cap="flat" cmpd="sng" algn="ctr">
-                      <a:solidFill>
-                        <a:srgbClr val="E3E8E9"/>
-                      </a:solidFill>
-                      <a:prstDash val="solid"/>
-                      <a:round/>
-                      <a:headEnd type="none" w="med" len="med"/>
-                      <a:tailEnd type="none" w="med" len="med"/>
-                    </a:lnL>
-                    <a:lnR w="6350" cap="flat" cmpd="sng" algn="ctr">
-                      <a:solidFill>
-                        <a:srgbClr val="E3E8E9"/>
-                      </a:solidFill>
-                      <a:prstDash val="solid"/>
-                      <a:round/>
-                      <a:headEnd type="none" w="med" len="med"/>
-                      <a:tailEnd type="none" w="med" len="med"/>
-                    </a:lnR>
-                    <a:lnT w="6350" cap="flat" cmpd="sng" algn="ctr">
-                      <a:solidFill>
-                        <a:srgbClr val="E3E8E9"/>
-                      </a:solidFill>
-                      <a:prstDash val="solid"/>
-                      <a:round/>
-                      <a:headEnd type="none" w="med" len="med"/>
-                      <a:tailEnd type="none" w="med" len="med"/>
-                    </a:lnT>
-                    <a:lnB w="6350" cap="flat" cmpd="sng" algn="ctr">
-                      <a:solidFill>
-                        <a:srgbClr val="E3E8E9"/>
-                      </a:solidFill>
-                      <a:prstDash val="solid"/>
-                      <a:round/>
-                      <a:headEnd type="none" w="med" len="med"/>
-                      <a:tailEnd type="none" w="med" len="med"/>
-                    </a:lnB>
-                    <a:solidFill>
-                      <a:srgbClr val="F0F4F5"/>
-                    </a:solidFill>
-                  </a:tcPr>
-                </a:tc>
-              </a:tr>
-              <a:tr h="288036">
-                <a:tc>
-                  <a:txBody>
-                    <a:bodyPr/>
-                    <a:lstStyle/>
-                    <a:p>
-                      <a:pPr indent="0" marL="0">
-                        <a:buNone/>
-                      </a:pPr>
-                      <a:r>
-                        <a:rPr lang="en-US" sz="1000" dirty="0">
-                          <a:solidFill>
-                            <a:srgbClr val="1C2B33"/>
-                          </a:solidFill>
-                          <a:latin typeface="Calibri" pitchFamily="34" charset="0"/>
-                          <a:ea typeface="Calibri" pitchFamily="34" charset="-122"/>
-                          <a:cs typeface="Calibri" pitchFamily="34" charset="-120"/>
-                        </a:rPr>
                         <a:t>Detectores de Chama</a:t>
                       </a:r>
                       <a:endParaRPr lang="en-US" sz="1000" dirty="0">
@@ -11521,6 +10973,554 @@
                           <a:ea typeface="Calibri" pitchFamily="34" charset="-122"/>
                           <a:cs typeface="Calibri" pitchFamily="34" charset="-120"/>
                         </a:rPr>
+                        <a:t>Boiler Chromalox</a:t>
+                      </a:r>
+                      <a:endParaRPr lang="en-US" sz="1000" dirty="0">
+                        <a:latin typeface="Calibri" charset="0"/>
+                        <a:ea typeface="Calibri" charset="0"/>
+                        <a:cs typeface="Calibri" charset="0"/>
+                      </a:endParaRPr>
+                    </a:p>
+                  </a:txBody>
+                  <a:tcPr marL="91440" marR="91440" marT="45720" marB="45720" anchor="ctr">
+                    <a:lnL w="6350" cap="flat" cmpd="sng" algn="ctr">
+                      <a:solidFill>
+                        <a:srgbClr val="E3E8E9"/>
+                      </a:solidFill>
+                      <a:prstDash val="solid"/>
+                      <a:round/>
+                      <a:headEnd type="none" w="med" len="med"/>
+                      <a:tailEnd type="none" w="med" len="med"/>
+                    </a:lnL>
+                    <a:lnR w="6350" cap="flat" cmpd="sng" algn="ctr">
+                      <a:solidFill>
+                        <a:srgbClr val="E3E8E9"/>
+                      </a:solidFill>
+                      <a:prstDash val="solid"/>
+                      <a:round/>
+                      <a:headEnd type="none" w="med" len="med"/>
+                      <a:tailEnd type="none" w="med" len="med"/>
+                    </a:lnR>
+                    <a:lnT w="6350" cap="flat" cmpd="sng" algn="ctr">
+                      <a:solidFill>
+                        <a:srgbClr val="E3E8E9"/>
+                      </a:solidFill>
+                      <a:prstDash val="solid"/>
+                      <a:round/>
+                      <a:headEnd type="none" w="med" len="med"/>
+                      <a:tailEnd type="none" w="med" len="med"/>
+                    </a:lnT>
+                    <a:lnB w="6350" cap="flat" cmpd="sng" algn="ctr">
+                      <a:solidFill>
+                        <a:srgbClr val="E3E8E9"/>
+                      </a:solidFill>
+                      <a:prstDash val="solid"/>
+                      <a:round/>
+                      <a:headEnd type="none" w="med" len="med"/>
+                      <a:tailEnd type="none" w="med" len="med"/>
+                    </a:lnB>
+                    <a:solidFill>
+                      <a:srgbClr val="F0F4F5"/>
+                    </a:solidFill>
+                  </a:tcPr>
+                </a:tc>
+                <a:tc>
+                  <a:txBody>
+                    <a:bodyPr/>
+                    <a:lstStyle/>
+                    <a:p>
+                      <a:pPr indent="0" marL="0">
+                        <a:buNone/>
+                      </a:pPr>
+                      <a:r>
+                        <a:rPr lang="en-US" sz="950" dirty="0">
+                          <a:solidFill>
+                            <a:srgbClr val="5B6B73"/>
+                          </a:solidFill>
+                          <a:latin typeface="Calibri" pitchFamily="34" charset="0"/>
+                          <a:ea typeface="Calibri" pitchFamily="34" charset="-122"/>
+                          <a:cs typeface="Calibri" pitchFamily="34" charset="-120"/>
+                        </a:rPr>
+                        <a:t>Eficiência de Produção</a:t>
+                      </a:r>
+                      <a:endParaRPr lang="en-US" sz="950" dirty="0">
+                        <a:latin typeface="Calibri" charset="0"/>
+                        <a:ea typeface="Calibri" charset="0"/>
+                        <a:cs typeface="Calibri" charset="0"/>
+                      </a:endParaRPr>
+                    </a:p>
+                  </a:txBody>
+                  <a:tcPr marL="91440" marR="91440" marT="45720" marB="45720" anchor="ctr">
+                    <a:lnL w="6350" cap="flat" cmpd="sng" algn="ctr">
+                      <a:solidFill>
+                        <a:srgbClr val="E3E8E9"/>
+                      </a:solidFill>
+                      <a:prstDash val="solid"/>
+                      <a:round/>
+                      <a:headEnd type="none" w="med" len="med"/>
+                      <a:tailEnd type="none" w="med" len="med"/>
+                    </a:lnL>
+                    <a:lnR w="6350" cap="flat" cmpd="sng" algn="ctr">
+                      <a:solidFill>
+                        <a:srgbClr val="E3E8E9"/>
+                      </a:solidFill>
+                      <a:prstDash val="solid"/>
+                      <a:round/>
+                      <a:headEnd type="none" w="med" len="med"/>
+                      <a:tailEnd type="none" w="med" len="med"/>
+                    </a:lnR>
+                    <a:lnT w="6350" cap="flat" cmpd="sng" algn="ctr">
+                      <a:solidFill>
+                        <a:srgbClr val="E3E8E9"/>
+                      </a:solidFill>
+                      <a:prstDash val="solid"/>
+                      <a:round/>
+                      <a:headEnd type="none" w="med" len="med"/>
+                      <a:tailEnd type="none" w="med" len="med"/>
+                    </a:lnT>
+                    <a:lnB w="6350" cap="flat" cmpd="sng" algn="ctr">
+                      <a:solidFill>
+                        <a:srgbClr val="E3E8E9"/>
+                      </a:solidFill>
+                      <a:prstDash val="solid"/>
+                      <a:round/>
+                      <a:headEnd type="none" w="med" len="med"/>
+                      <a:tailEnd type="none" w="med" len="med"/>
+                    </a:lnB>
+                    <a:solidFill>
+                      <a:srgbClr val="F0F4F5"/>
+                    </a:solidFill>
+                  </a:tcPr>
+                </a:tc>
+                <a:tc>
+                  <a:txBody>
+                    <a:bodyPr/>
+                    <a:lstStyle/>
+                    <a:p>
+                      <a:pPr indent="0" marL="0">
+                        <a:buNone/>
+                      </a:pPr>
+                      <a:r>
+                        <a:rPr lang="en-US" sz="950" dirty="0">
+                          <a:solidFill>
+                            <a:srgbClr val="5B6B73"/>
+                          </a:solidFill>
+                          <a:latin typeface="Calibri" pitchFamily="34" charset="0"/>
+                          <a:ea typeface="Calibri" pitchFamily="34" charset="-122"/>
+                          <a:cs typeface="Calibri" pitchFamily="34" charset="-120"/>
+                        </a:rPr>
+                        <a:t>Projetos</a:t>
+                      </a:r>
+                      <a:endParaRPr lang="en-US" sz="950" dirty="0">
+                        <a:latin typeface="Calibri" charset="0"/>
+                        <a:ea typeface="Calibri" charset="0"/>
+                        <a:cs typeface="Calibri" charset="0"/>
+                      </a:endParaRPr>
+                    </a:p>
+                  </a:txBody>
+                  <a:tcPr marL="91440" marR="91440" marT="45720" marB="45720" anchor="ctr">
+                    <a:lnL w="6350" cap="flat" cmpd="sng" algn="ctr">
+                      <a:solidFill>
+                        <a:srgbClr val="E3E8E9"/>
+                      </a:solidFill>
+                      <a:prstDash val="solid"/>
+                      <a:round/>
+                      <a:headEnd type="none" w="med" len="med"/>
+                      <a:tailEnd type="none" w="med" len="med"/>
+                    </a:lnL>
+                    <a:lnR w="6350" cap="flat" cmpd="sng" algn="ctr">
+                      <a:solidFill>
+                        <a:srgbClr val="E3E8E9"/>
+                      </a:solidFill>
+                      <a:prstDash val="solid"/>
+                      <a:round/>
+                      <a:headEnd type="none" w="med" len="med"/>
+                      <a:tailEnd type="none" w="med" len="med"/>
+                    </a:lnR>
+                    <a:lnT w="6350" cap="flat" cmpd="sng" algn="ctr">
+                      <a:solidFill>
+                        <a:srgbClr val="E3E8E9"/>
+                      </a:solidFill>
+                      <a:prstDash val="solid"/>
+                      <a:round/>
+                      <a:headEnd type="none" w="med" len="med"/>
+                      <a:tailEnd type="none" w="med" len="med"/>
+                    </a:lnT>
+                    <a:lnB w="6350" cap="flat" cmpd="sng" algn="ctr">
+                      <a:solidFill>
+                        <a:srgbClr val="E3E8E9"/>
+                      </a:solidFill>
+                      <a:prstDash val="solid"/>
+                      <a:round/>
+                      <a:headEnd type="none" w="med" len="med"/>
+                      <a:tailEnd type="none" w="med" len="med"/>
+                    </a:lnB>
+                    <a:solidFill>
+                      <a:srgbClr val="F0F4F5"/>
+                    </a:solidFill>
+                  </a:tcPr>
+                </a:tc>
+                <a:tc>
+                  <a:txBody>
+                    <a:bodyPr/>
+                    <a:lstStyle/>
+                    <a:p>
+                      <a:pPr algn="r" indent="0" marL="0">
+                        <a:buNone/>
+                      </a:pPr>
+                      <a:r>
+                        <a:rPr lang="en-US" sz="1000" b="1" dirty="0">
+                          <a:solidFill>
+                            <a:srgbClr val="0B2A3D"/>
+                          </a:solidFill>
+                          <a:latin typeface="Calibri" pitchFamily="34" charset="0"/>
+                          <a:ea typeface="Calibri" pitchFamily="34" charset="-122"/>
+                          <a:cs typeface="Calibri" pitchFamily="34" charset="-120"/>
+                        </a:rPr>
+                        <a:t>US$ 523,6 mil</a:t>
+                      </a:r>
+                      <a:endParaRPr lang="en-US" sz="1000" dirty="0">
+                        <a:latin typeface="Calibri" charset="0"/>
+                        <a:ea typeface="Calibri" charset="0"/>
+                        <a:cs typeface="Calibri" charset="0"/>
+                      </a:endParaRPr>
+                    </a:p>
+                  </a:txBody>
+                  <a:tcPr marL="91440" marR="91440" marT="45720" marB="45720" anchor="ctr">
+                    <a:lnL w="6350" cap="flat" cmpd="sng" algn="ctr">
+                      <a:solidFill>
+                        <a:srgbClr val="E3E8E9"/>
+                      </a:solidFill>
+                      <a:prstDash val="solid"/>
+                      <a:round/>
+                      <a:headEnd type="none" w="med" len="med"/>
+                      <a:tailEnd type="none" w="med" len="med"/>
+                    </a:lnL>
+                    <a:lnR w="6350" cap="flat" cmpd="sng" algn="ctr">
+                      <a:solidFill>
+                        <a:srgbClr val="E3E8E9"/>
+                      </a:solidFill>
+                      <a:prstDash val="solid"/>
+                      <a:round/>
+                      <a:headEnd type="none" w="med" len="med"/>
+                      <a:tailEnd type="none" w="med" len="med"/>
+                    </a:lnR>
+                    <a:lnT w="6350" cap="flat" cmpd="sng" algn="ctr">
+                      <a:solidFill>
+                        <a:srgbClr val="E3E8E9"/>
+                      </a:solidFill>
+                      <a:prstDash val="solid"/>
+                      <a:round/>
+                      <a:headEnd type="none" w="med" len="med"/>
+                      <a:tailEnd type="none" w="med" len="med"/>
+                    </a:lnT>
+                    <a:lnB w="6350" cap="flat" cmpd="sng" algn="ctr">
+                      <a:solidFill>
+                        <a:srgbClr val="E3E8E9"/>
+                      </a:solidFill>
+                      <a:prstDash val="solid"/>
+                      <a:round/>
+                      <a:headEnd type="none" w="med" len="med"/>
+                      <a:tailEnd type="none" w="med" len="med"/>
+                    </a:lnB>
+                    <a:solidFill>
+                      <a:srgbClr val="F0F4F5"/>
+                    </a:solidFill>
+                  </a:tcPr>
+                </a:tc>
+              </a:tr>
+              <a:tr h="288036">
+                <a:tc>
+                  <a:txBody>
+                    <a:bodyPr/>
+                    <a:lstStyle/>
+                    <a:p>
+                      <a:pPr indent="0" marL="0">
+                        <a:buNone/>
+                      </a:pPr>
+                      <a:r>
+                        <a:rPr lang="en-US" sz="1000" dirty="0">
+                          <a:solidFill>
+                            <a:srgbClr val="1C2B33"/>
+                          </a:solidFill>
+                          <a:latin typeface="Calibri" pitchFamily="34" charset="0"/>
+                          <a:ea typeface="Calibri" pitchFamily="34" charset="-122"/>
+                          <a:cs typeface="Calibri" pitchFamily="34" charset="-120"/>
+                        </a:rPr>
+                        <a:t>Water Mist</a:t>
+                      </a:r>
+                      <a:endParaRPr lang="en-US" sz="1000" dirty="0">
+                        <a:latin typeface="Calibri" charset="0"/>
+                        <a:ea typeface="Calibri" charset="0"/>
+                        <a:cs typeface="Calibri" charset="0"/>
+                      </a:endParaRPr>
+                    </a:p>
+                  </a:txBody>
+                  <a:tcPr marL="91440" marR="91440" marT="45720" marB="45720" anchor="ctr">
+                    <a:lnL w="6350" cap="flat" cmpd="sng" algn="ctr">
+                      <a:solidFill>
+                        <a:srgbClr val="E3E8E9"/>
+                      </a:solidFill>
+                      <a:prstDash val="solid"/>
+                      <a:round/>
+                      <a:headEnd type="none" w="med" len="med"/>
+                      <a:tailEnd type="none" w="med" len="med"/>
+                    </a:lnL>
+                    <a:lnR w="6350" cap="flat" cmpd="sng" algn="ctr">
+                      <a:solidFill>
+                        <a:srgbClr val="E3E8E9"/>
+                      </a:solidFill>
+                      <a:prstDash val="solid"/>
+                      <a:round/>
+                      <a:headEnd type="none" w="med" len="med"/>
+                      <a:tailEnd type="none" w="med" len="med"/>
+                    </a:lnR>
+                    <a:lnT w="6350" cap="flat" cmpd="sng" algn="ctr">
+                      <a:solidFill>
+                        <a:srgbClr val="E3E8E9"/>
+                      </a:solidFill>
+                      <a:prstDash val="solid"/>
+                      <a:round/>
+                      <a:headEnd type="none" w="med" len="med"/>
+                      <a:tailEnd type="none" w="med" len="med"/>
+                    </a:lnT>
+                    <a:lnB w="6350" cap="flat" cmpd="sng" algn="ctr">
+                      <a:solidFill>
+                        <a:srgbClr val="E3E8E9"/>
+                      </a:solidFill>
+                      <a:prstDash val="solid"/>
+                      <a:round/>
+                      <a:headEnd type="none" w="med" len="med"/>
+                      <a:tailEnd type="none" w="med" len="med"/>
+                    </a:lnB>
+                    <a:solidFill>
+                      <a:srgbClr val="FFFFFF"/>
+                    </a:solidFill>
+                  </a:tcPr>
+                </a:tc>
+                <a:tc>
+                  <a:txBody>
+                    <a:bodyPr/>
+                    <a:lstStyle/>
+                    <a:p>
+                      <a:pPr indent="0" marL="0">
+                        <a:buNone/>
+                      </a:pPr>
+                      <a:r>
+                        <a:rPr lang="en-US" sz="950" dirty="0">
+                          <a:solidFill>
+                            <a:srgbClr val="5B6B73"/>
+                          </a:solidFill>
+                          <a:latin typeface="Calibri" pitchFamily="34" charset="0"/>
+                          <a:ea typeface="Calibri" pitchFamily="34" charset="-122"/>
+                          <a:cs typeface="Calibri" pitchFamily="34" charset="-120"/>
+                        </a:rPr>
+                        <a:t>Bem Estar/Segurança</a:t>
+                      </a:r>
+                      <a:endParaRPr lang="en-US" sz="950" dirty="0">
+                        <a:latin typeface="Calibri" charset="0"/>
+                        <a:ea typeface="Calibri" charset="0"/>
+                        <a:cs typeface="Calibri" charset="0"/>
+                      </a:endParaRPr>
+                    </a:p>
+                  </a:txBody>
+                  <a:tcPr marL="91440" marR="91440" marT="45720" marB="45720" anchor="ctr">
+                    <a:lnL w="6350" cap="flat" cmpd="sng" algn="ctr">
+                      <a:solidFill>
+                        <a:srgbClr val="E3E8E9"/>
+                      </a:solidFill>
+                      <a:prstDash val="solid"/>
+                      <a:round/>
+                      <a:headEnd type="none" w="med" len="med"/>
+                      <a:tailEnd type="none" w="med" len="med"/>
+                    </a:lnL>
+                    <a:lnR w="6350" cap="flat" cmpd="sng" algn="ctr">
+                      <a:solidFill>
+                        <a:srgbClr val="E3E8E9"/>
+                      </a:solidFill>
+                      <a:prstDash val="solid"/>
+                      <a:round/>
+                      <a:headEnd type="none" w="med" len="med"/>
+                      <a:tailEnd type="none" w="med" len="med"/>
+                    </a:lnR>
+                    <a:lnT w="6350" cap="flat" cmpd="sng" algn="ctr">
+                      <a:solidFill>
+                        <a:srgbClr val="E3E8E9"/>
+                      </a:solidFill>
+                      <a:prstDash val="solid"/>
+                      <a:round/>
+                      <a:headEnd type="none" w="med" len="med"/>
+                      <a:tailEnd type="none" w="med" len="med"/>
+                    </a:lnT>
+                    <a:lnB w="6350" cap="flat" cmpd="sng" algn="ctr">
+                      <a:solidFill>
+                        <a:srgbClr val="E3E8E9"/>
+                      </a:solidFill>
+                      <a:prstDash val="solid"/>
+                      <a:round/>
+                      <a:headEnd type="none" w="med" len="med"/>
+                      <a:tailEnd type="none" w="med" len="med"/>
+                    </a:lnB>
+                    <a:solidFill>
+                      <a:srgbClr val="FFFFFF"/>
+                    </a:solidFill>
+                  </a:tcPr>
+                </a:tc>
+                <a:tc>
+                  <a:txBody>
+                    <a:bodyPr/>
+                    <a:lstStyle/>
+                    <a:p>
+                      <a:pPr indent="0" marL="0">
+                        <a:buNone/>
+                      </a:pPr>
+                      <a:r>
+                        <a:rPr lang="en-US" sz="950" dirty="0">
+                          <a:solidFill>
+                            <a:srgbClr val="5B6B73"/>
+                          </a:solidFill>
+                          <a:latin typeface="Calibri" pitchFamily="34" charset="0"/>
+                          <a:ea typeface="Calibri" pitchFamily="34" charset="-122"/>
+                          <a:cs typeface="Calibri" pitchFamily="34" charset="-120"/>
+                        </a:rPr>
+                        <a:t>Projetos</a:t>
+                      </a:r>
+                      <a:endParaRPr lang="en-US" sz="950" dirty="0">
+                        <a:latin typeface="Calibri" charset="0"/>
+                        <a:ea typeface="Calibri" charset="0"/>
+                        <a:cs typeface="Calibri" charset="0"/>
+                      </a:endParaRPr>
+                    </a:p>
+                  </a:txBody>
+                  <a:tcPr marL="91440" marR="91440" marT="45720" marB="45720" anchor="ctr">
+                    <a:lnL w="6350" cap="flat" cmpd="sng" algn="ctr">
+                      <a:solidFill>
+                        <a:srgbClr val="E3E8E9"/>
+                      </a:solidFill>
+                      <a:prstDash val="solid"/>
+                      <a:round/>
+                      <a:headEnd type="none" w="med" len="med"/>
+                      <a:tailEnd type="none" w="med" len="med"/>
+                    </a:lnL>
+                    <a:lnR w="6350" cap="flat" cmpd="sng" algn="ctr">
+                      <a:solidFill>
+                        <a:srgbClr val="E3E8E9"/>
+                      </a:solidFill>
+                      <a:prstDash val="solid"/>
+                      <a:round/>
+                      <a:headEnd type="none" w="med" len="med"/>
+                      <a:tailEnd type="none" w="med" len="med"/>
+                    </a:lnR>
+                    <a:lnT w="6350" cap="flat" cmpd="sng" algn="ctr">
+                      <a:solidFill>
+                        <a:srgbClr val="E3E8E9"/>
+                      </a:solidFill>
+                      <a:prstDash val="solid"/>
+                      <a:round/>
+                      <a:headEnd type="none" w="med" len="med"/>
+                      <a:tailEnd type="none" w="med" len="med"/>
+                    </a:lnT>
+                    <a:lnB w="6350" cap="flat" cmpd="sng" algn="ctr">
+                      <a:solidFill>
+                        <a:srgbClr val="E3E8E9"/>
+                      </a:solidFill>
+                      <a:prstDash val="solid"/>
+                      <a:round/>
+                      <a:headEnd type="none" w="med" len="med"/>
+                      <a:tailEnd type="none" w="med" len="med"/>
+                    </a:lnB>
+                    <a:solidFill>
+                      <a:srgbClr val="FFFFFF"/>
+                    </a:solidFill>
+                  </a:tcPr>
+                </a:tc>
+                <a:tc>
+                  <a:txBody>
+                    <a:bodyPr/>
+                    <a:lstStyle/>
+                    <a:p>
+                      <a:pPr algn="r" indent="0" marL="0">
+                        <a:buNone/>
+                      </a:pPr>
+                      <a:r>
+                        <a:rPr lang="en-US" sz="1000" b="1" dirty="0">
+                          <a:solidFill>
+                            <a:srgbClr val="0B2A3D"/>
+                          </a:solidFill>
+                          <a:latin typeface="Calibri" pitchFamily="34" charset="0"/>
+                          <a:ea typeface="Calibri" pitchFamily="34" charset="-122"/>
+                          <a:cs typeface="Calibri" pitchFamily="34" charset="-120"/>
+                        </a:rPr>
+                        <a:t>US$ 508,2 mil</a:t>
+                      </a:r>
+                      <a:endParaRPr lang="en-US" sz="1000" dirty="0">
+                        <a:latin typeface="Calibri" charset="0"/>
+                        <a:ea typeface="Calibri" charset="0"/>
+                        <a:cs typeface="Calibri" charset="0"/>
+                      </a:endParaRPr>
+                    </a:p>
+                  </a:txBody>
+                  <a:tcPr marL="91440" marR="91440" marT="45720" marB="45720" anchor="ctr">
+                    <a:lnL w="6350" cap="flat" cmpd="sng" algn="ctr">
+                      <a:solidFill>
+                        <a:srgbClr val="E3E8E9"/>
+                      </a:solidFill>
+                      <a:prstDash val="solid"/>
+                      <a:round/>
+                      <a:headEnd type="none" w="med" len="med"/>
+                      <a:tailEnd type="none" w="med" len="med"/>
+                    </a:lnL>
+                    <a:lnR w="6350" cap="flat" cmpd="sng" algn="ctr">
+                      <a:solidFill>
+                        <a:srgbClr val="E3E8E9"/>
+                      </a:solidFill>
+                      <a:prstDash val="solid"/>
+                      <a:round/>
+                      <a:headEnd type="none" w="med" len="med"/>
+                      <a:tailEnd type="none" w="med" len="med"/>
+                    </a:lnR>
+                    <a:lnT w="6350" cap="flat" cmpd="sng" algn="ctr">
+                      <a:solidFill>
+                        <a:srgbClr val="E3E8E9"/>
+                      </a:solidFill>
+                      <a:prstDash val="solid"/>
+                      <a:round/>
+                      <a:headEnd type="none" w="med" len="med"/>
+                      <a:tailEnd type="none" w="med" len="med"/>
+                    </a:lnT>
+                    <a:lnB w="6350" cap="flat" cmpd="sng" algn="ctr">
+                      <a:solidFill>
+                        <a:srgbClr val="E3E8E9"/>
+                      </a:solidFill>
+                      <a:prstDash val="solid"/>
+                      <a:round/>
+                      <a:headEnd type="none" w="med" len="med"/>
+                      <a:tailEnd type="none" w="med" len="med"/>
+                    </a:lnB>
+                    <a:solidFill>
+                      <a:srgbClr val="FFFFFF"/>
+                    </a:solidFill>
+                  </a:tcPr>
+                </a:tc>
+              </a:tr>
+              <a:tr h="288036">
+                <a:tc>
+                  <a:txBody>
+                    <a:bodyPr/>
+                    <a:lstStyle/>
+                    <a:p>
+                      <a:pPr indent="0" marL="0">
+                        <a:buNone/>
+                      </a:pPr>
+                      <a:r>
+                        <a:rPr lang="en-US" sz="1000" dirty="0">
+                          <a:solidFill>
+                            <a:srgbClr val="1C2B33"/>
+                          </a:solidFill>
+                          <a:latin typeface="Calibri" pitchFamily="34" charset="0"/>
+                          <a:ea typeface="Calibri" pitchFamily="34" charset="-122"/>
+                          <a:cs typeface="Calibri" pitchFamily="34" charset="-120"/>
+                        </a:rPr>
                         <a:t>TBM - Junta de expansão exhaust - TURBINAS</a:t>
                       </a:r>
                       <a:endParaRPr lang="en-US" sz="1000" dirty="0">
@@ -11725,555 +11725,7 @@
                           <a:ea typeface="Calibri" pitchFamily="34" charset="-122"/>
                           <a:cs typeface="Calibri" pitchFamily="34" charset="-120"/>
                         </a:rPr>
-                        <a:t>US$ 560,7 mil</a:t>
-                      </a:r>
-                      <a:endParaRPr lang="en-US" sz="1000" dirty="0">
-                        <a:latin typeface="Calibri" charset="0"/>
-                        <a:ea typeface="Calibri" charset="0"/>
-                        <a:cs typeface="Calibri" charset="0"/>
-                      </a:endParaRPr>
-                    </a:p>
-                  </a:txBody>
-                  <a:tcPr marL="91440" marR="91440" marT="45720" marB="45720" anchor="ctr">
-                    <a:lnL w="6350" cap="flat" cmpd="sng" algn="ctr">
-                      <a:solidFill>
-                        <a:srgbClr val="E3E8E9"/>
-                      </a:solidFill>
-                      <a:prstDash val="solid"/>
-                      <a:round/>
-                      <a:headEnd type="none" w="med" len="med"/>
-                      <a:tailEnd type="none" w="med" len="med"/>
-                    </a:lnL>
-                    <a:lnR w="6350" cap="flat" cmpd="sng" algn="ctr">
-                      <a:solidFill>
-                        <a:srgbClr val="E3E8E9"/>
-                      </a:solidFill>
-                      <a:prstDash val="solid"/>
-                      <a:round/>
-                      <a:headEnd type="none" w="med" len="med"/>
-                      <a:tailEnd type="none" w="med" len="med"/>
-                    </a:lnR>
-                    <a:lnT w="6350" cap="flat" cmpd="sng" algn="ctr">
-                      <a:solidFill>
-                        <a:srgbClr val="E3E8E9"/>
-                      </a:solidFill>
-                      <a:prstDash val="solid"/>
-                      <a:round/>
-                      <a:headEnd type="none" w="med" len="med"/>
-                      <a:tailEnd type="none" w="med" len="med"/>
-                    </a:lnT>
-                    <a:lnB w="6350" cap="flat" cmpd="sng" algn="ctr">
-                      <a:solidFill>
-                        <a:srgbClr val="E3E8E9"/>
-                      </a:solidFill>
-                      <a:prstDash val="solid"/>
-                      <a:round/>
-                      <a:headEnd type="none" w="med" len="med"/>
-                      <a:tailEnd type="none" w="med" len="med"/>
-                    </a:lnB>
-                    <a:solidFill>
-                      <a:srgbClr val="F0F4F5"/>
-                    </a:solidFill>
-                  </a:tcPr>
-                </a:tc>
-              </a:tr>
-              <a:tr h="288036">
-                <a:tc>
-                  <a:txBody>
-                    <a:bodyPr/>
-                    <a:lstStyle/>
-                    <a:p>
-                      <a:pPr indent="0" marL="0">
-                        <a:buNone/>
-                      </a:pPr>
-                      <a:r>
-                        <a:rPr lang="en-US" sz="1000" dirty="0">
-                          <a:solidFill>
-                            <a:srgbClr val="1C2B33"/>
-                          </a:solidFill>
-                          <a:latin typeface="Calibri" pitchFamily="34" charset="0"/>
-                          <a:ea typeface="Calibri" pitchFamily="34" charset="-122"/>
-                          <a:cs typeface="Calibri" pitchFamily="34" charset="-120"/>
-                        </a:rPr>
-                        <a:t>Combate a Incêndio - Revamp das cabines de water mist</a:t>
-                      </a:r>
-                      <a:endParaRPr lang="en-US" sz="1000" dirty="0">
-                        <a:latin typeface="Calibri" charset="0"/>
-                        <a:ea typeface="Calibri" charset="0"/>
-                        <a:cs typeface="Calibri" charset="0"/>
-                      </a:endParaRPr>
-                    </a:p>
-                  </a:txBody>
-                  <a:tcPr marL="91440" marR="91440" marT="45720" marB="45720" anchor="ctr">
-                    <a:lnL w="6350" cap="flat" cmpd="sng" algn="ctr">
-                      <a:solidFill>
-                        <a:srgbClr val="E3E8E9"/>
-                      </a:solidFill>
-                      <a:prstDash val="solid"/>
-                      <a:round/>
-                      <a:headEnd type="none" w="med" len="med"/>
-                      <a:tailEnd type="none" w="med" len="med"/>
-                    </a:lnL>
-                    <a:lnR w="6350" cap="flat" cmpd="sng" algn="ctr">
-                      <a:solidFill>
-                        <a:srgbClr val="E3E8E9"/>
-                      </a:solidFill>
-                      <a:prstDash val="solid"/>
-                      <a:round/>
-                      <a:headEnd type="none" w="med" len="med"/>
-                      <a:tailEnd type="none" w="med" len="med"/>
-                    </a:lnR>
-                    <a:lnT w="6350" cap="flat" cmpd="sng" algn="ctr">
-                      <a:solidFill>
-                        <a:srgbClr val="E3E8E9"/>
-                      </a:solidFill>
-                      <a:prstDash val="solid"/>
-                      <a:round/>
-                      <a:headEnd type="none" w="med" len="med"/>
-                      <a:tailEnd type="none" w="med" len="med"/>
-                    </a:lnT>
-                    <a:lnB w="6350" cap="flat" cmpd="sng" algn="ctr">
-                      <a:solidFill>
-                        <a:srgbClr val="E3E8E9"/>
-                      </a:solidFill>
-                      <a:prstDash val="solid"/>
-                      <a:round/>
-                      <a:headEnd type="none" w="med" len="med"/>
-                      <a:tailEnd type="none" w="med" len="med"/>
-                    </a:lnB>
-                    <a:solidFill>
-                      <a:srgbClr val="FFFFFF"/>
-                    </a:solidFill>
-                  </a:tcPr>
-                </a:tc>
-                <a:tc>
-                  <a:txBody>
-                    <a:bodyPr/>
-                    <a:lstStyle/>
-                    <a:p>
-                      <a:pPr indent="0" marL="0">
-                        <a:buNone/>
-                      </a:pPr>
-                      <a:r>
-                        <a:rPr lang="en-US" sz="950" dirty="0">
-                          <a:solidFill>
-                            <a:srgbClr val="5B6B73"/>
-                          </a:solidFill>
-                          <a:latin typeface="Calibri" pitchFamily="34" charset="0"/>
-                          <a:ea typeface="Calibri" pitchFamily="34" charset="-122"/>
-                          <a:cs typeface="Calibri" pitchFamily="34" charset="-120"/>
-                        </a:rPr>
-                        <a:t>Bem Estar/Segurança</a:t>
-                      </a:r>
-                      <a:endParaRPr lang="en-US" sz="950" dirty="0">
-                        <a:latin typeface="Calibri" charset="0"/>
-                        <a:ea typeface="Calibri" charset="0"/>
-                        <a:cs typeface="Calibri" charset="0"/>
-                      </a:endParaRPr>
-                    </a:p>
-                  </a:txBody>
-                  <a:tcPr marL="91440" marR="91440" marT="45720" marB="45720" anchor="ctr">
-                    <a:lnL w="6350" cap="flat" cmpd="sng" algn="ctr">
-                      <a:solidFill>
-                        <a:srgbClr val="E3E8E9"/>
-                      </a:solidFill>
-                      <a:prstDash val="solid"/>
-                      <a:round/>
-                      <a:headEnd type="none" w="med" len="med"/>
-                      <a:tailEnd type="none" w="med" len="med"/>
-                    </a:lnL>
-                    <a:lnR w="6350" cap="flat" cmpd="sng" algn="ctr">
-                      <a:solidFill>
-                        <a:srgbClr val="E3E8E9"/>
-                      </a:solidFill>
-                      <a:prstDash val="solid"/>
-                      <a:round/>
-                      <a:headEnd type="none" w="med" len="med"/>
-                      <a:tailEnd type="none" w="med" len="med"/>
-                    </a:lnR>
-                    <a:lnT w="6350" cap="flat" cmpd="sng" algn="ctr">
-                      <a:solidFill>
-                        <a:srgbClr val="E3E8E9"/>
-                      </a:solidFill>
-                      <a:prstDash val="solid"/>
-                      <a:round/>
-                      <a:headEnd type="none" w="med" len="med"/>
-                      <a:tailEnd type="none" w="med" len="med"/>
-                    </a:lnT>
-                    <a:lnB w="6350" cap="flat" cmpd="sng" algn="ctr">
-                      <a:solidFill>
-                        <a:srgbClr val="E3E8E9"/>
-                      </a:solidFill>
-                      <a:prstDash val="solid"/>
-                      <a:round/>
-                      <a:headEnd type="none" w="med" len="med"/>
-                      <a:tailEnd type="none" w="med" len="med"/>
-                    </a:lnB>
-                    <a:solidFill>
-                      <a:srgbClr val="FFFFFF"/>
-                    </a:solidFill>
-                  </a:tcPr>
-                </a:tc>
-                <a:tc>
-                  <a:txBody>
-                    <a:bodyPr/>
-                    <a:lstStyle/>
-                    <a:p>
-                      <a:pPr indent="0" marL="0">
-                        <a:buNone/>
-                      </a:pPr>
-                      <a:r>
-                        <a:rPr lang="en-US" sz="950" dirty="0">
-                          <a:solidFill>
-                            <a:srgbClr val="5B6B73"/>
-                          </a:solidFill>
-                          <a:latin typeface="Calibri" pitchFamily="34" charset="0"/>
-                          <a:ea typeface="Calibri" pitchFamily="34" charset="-122"/>
-                          <a:cs typeface="Calibri" pitchFamily="34" charset="-120"/>
-                        </a:rPr>
-                        <a:t>Saúde e Segurança Ocupacional</a:t>
-                      </a:r>
-                      <a:endParaRPr lang="en-US" sz="950" dirty="0">
-                        <a:latin typeface="Calibri" charset="0"/>
-                        <a:ea typeface="Calibri" charset="0"/>
-                        <a:cs typeface="Calibri" charset="0"/>
-                      </a:endParaRPr>
-                    </a:p>
-                  </a:txBody>
-                  <a:tcPr marL="91440" marR="91440" marT="45720" marB="45720" anchor="ctr">
-                    <a:lnL w="6350" cap="flat" cmpd="sng" algn="ctr">
-                      <a:solidFill>
-                        <a:srgbClr val="E3E8E9"/>
-                      </a:solidFill>
-                      <a:prstDash val="solid"/>
-                      <a:round/>
-                      <a:headEnd type="none" w="med" len="med"/>
-                      <a:tailEnd type="none" w="med" len="med"/>
-                    </a:lnL>
-                    <a:lnR w="6350" cap="flat" cmpd="sng" algn="ctr">
-                      <a:solidFill>
-                        <a:srgbClr val="E3E8E9"/>
-                      </a:solidFill>
-                      <a:prstDash val="solid"/>
-                      <a:round/>
-                      <a:headEnd type="none" w="med" len="med"/>
-                      <a:tailEnd type="none" w="med" len="med"/>
-                    </a:lnR>
-                    <a:lnT w="6350" cap="flat" cmpd="sng" algn="ctr">
-                      <a:solidFill>
-                        <a:srgbClr val="E3E8E9"/>
-                      </a:solidFill>
-                      <a:prstDash val="solid"/>
-                      <a:round/>
-                      <a:headEnd type="none" w="med" len="med"/>
-                      <a:tailEnd type="none" w="med" len="med"/>
-                    </a:lnT>
-                    <a:lnB w="6350" cap="flat" cmpd="sng" algn="ctr">
-                      <a:solidFill>
-                        <a:srgbClr val="E3E8E9"/>
-                      </a:solidFill>
-                      <a:prstDash val="solid"/>
-                      <a:round/>
-                      <a:headEnd type="none" w="med" len="med"/>
-                      <a:tailEnd type="none" w="med" len="med"/>
-                    </a:lnB>
-                    <a:solidFill>
-                      <a:srgbClr val="FFFFFF"/>
-                    </a:solidFill>
-                  </a:tcPr>
-                </a:tc>
-                <a:tc>
-                  <a:txBody>
-                    <a:bodyPr/>
-                    <a:lstStyle/>
-                    <a:p>
-                      <a:pPr algn="r" indent="0" marL="0">
-                        <a:buNone/>
-                      </a:pPr>
-                      <a:r>
-                        <a:rPr lang="en-US" sz="1000" b="1" dirty="0">
-                          <a:solidFill>
-                            <a:srgbClr val="0B2A3D"/>
-                          </a:solidFill>
-                          <a:latin typeface="Calibri" pitchFamily="34" charset="0"/>
-                          <a:ea typeface="Calibri" pitchFamily="34" charset="-122"/>
-                          <a:cs typeface="Calibri" pitchFamily="34" charset="-120"/>
-                        </a:rPr>
-                        <a:t>US$ 500,0 mil</a:t>
-                      </a:r>
-                      <a:endParaRPr lang="en-US" sz="1000" dirty="0">
-                        <a:latin typeface="Calibri" charset="0"/>
-                        <a:ea typeface="Calibri" charset="0"/>
-                        <a:cs typeface="Calibri" charset="0"/>
-                      </a:endParaRPr>
-                    </a:p>
-                  </a:txBody>
-                  <a:tcPr marL="91440" marR="91440" marT="45720" marB="45720" anchor="ctr">
-                    <a:lnL w="6350" cap="flat" cmpd="sng" algn="ctr">
-                      <a:solidFill>
-                        <a:srgbClr val="E3E8E9"/>
-                      </a:solidFill>
-                      <a:prstDash val="solid"/>
-                      <a:round/>
-                      <a:headEnd type="none" w="med" len="med"/>
-                      <a:tailEnd type="none" w="med" len="med"/>
-                    </a:lnL>
-                    <a:lnR w="6350" cap="flat" cmpd="sng" algn="ctr">
-                      <a:solidFill>
-                        <a:srgbClr val="E3E8E9"/>
-                      </a:solidFill>
-                      <a:prstDash val="solid"/>
-                      <a:round/>
-                      <a:headEnd type="none" w="med" len="med"/>
-                      <a:tailEnd type="none" w="med" len="med"/>
-                    </a:lnR>
-                    <a:lnT w="6350" cap="flat" cmpd="sng" algn="ctr">
-                      <a:solidFill>
-                        <a:srgbClr val="E3E8E9"/>
-                      </a:solidFill>
-                      <a:prstDash val="solid"/>
-                      <a:round/>
-                      <a:headEnd type="none" w="med" len="med"/>
-                      <a:tailEnd type="none" w="med" len="med"/>
-                    </a:lnT>
-                    <a:lnB w="6350" cap="flat" cmpd="sng" algn="ctr">
-                      <a:solidFill>
-                        <a:srgbClr val="E3E8E9"/>
-                      </a:solidFill>
-                      <a:prstDash val="solid"/>
-                      <a:round/>
-                      <a:headEnd type="none" w="med" len="med"/>
-                      <a:tailEnd type="none" w="med" len="med"/>
-                    </a:lnB>
-                    <a:solidFill>
-                      <a:srgbClr val="FFFFFF"/>
-                    </a:solidFill>
-                  </a:tcPr>
-                </a:tc>
-              </a:tr>
-              <a:tr h="288036">
-                <a:tc>
-                  <a:txBody>
-                    <a:bodyPr/>
-                    <a:lstStyle/>
-                    <a:p>
-                      <a:pPr indent="0" marL="0">
-                        <a:buNone/>
-                      </a:pPr>
-                      <a:r>
-                        <a:rPr lang="en-US" sz="1000" dirty="0">
-                          <a:solidFill>
-                            <a:srgbClr val="1C2B33"/>
-                          </a:solidFill>
-                          <a:latin typeface="Calibri" pitchFamily="34" charset="0"/>
-                          <a:ea typeface="Calibri" pitchFamily="34" charset="-122"/>
-                          <a:cs typeface="Calibri" pitchFamily="34" charset="-120"/>
-                        </a:rPr>
-                        <a:t>Water Mist</a:t>
-                      </a:r>
-                      <a:endParaRPr lang="en-US" sz="1000" dirty="0">
-                        <a:latin typeface="Calibri" charset="0"/>
-                        <a:ea typeface="Calibri" charset="0"/>
-                        <a:cs typeface="Calibri" charset="0"/>
-                      </a:endParaRPr>
-                    </a:p>
-                  </a:txBody>
-                  <a:tcPr marL="91440" marR="91440" marT="45720" marB="45720" anchor="ctr">
-                    <a:lnL w="6350" cap="flat" cmpd="sng" algn="ctr">
-                      <a:solidFill>
-                        <a:srgbClr val="E3E8E9"/>
-                      </a:solidFill>
-                      <a:prstDash val="solid"/>
-                      <a:round/>
-                      <a:headEnd type="none" w="med" len="med"/>
-                      <a:tailEnd type="none" w="med" len="med"/>
-                    </a:lnL>
-                    <a:lnR w="6350" cap="flat" cmpd="sng" algn="ctr">
-                      <a:solidFill>
-                        <a:srgbClr val="E3E8E9"/>
-                      </a:solidFill>
-                      <a:prstDash val="solid"/>
-                      <a:round/>
-                      <a:headEnd type="none" w="med" len="med"/>
-                      <a:tailEnd type="none" w="med" len="med"/>
-                    </a:lnR>
-                    <a:lnT w="6350" cap="flat" cmpd="sng" algn="ctr">
-                      <a:solidFill>
-                        <a:srgbClr val="E3E8E9"/>
-                      </a:solidFill>
-                      <a:prstDash val="solid"/>
-                      <a:round/>
-                      <a:headEnd type="none" w="med" len="med"/>
-                      <a:tailEnd type="none" w="med" len="med"/>
-                    </a:lnT>
-                    <a:lnB w="6350" cap="flat" cmpd="sng" algn="ctr">
-                      <a:solidFill>
-                        <a:srgbClr val="E3E8E9"/>
-                      </a:solidFill>
-                      <a:prstDash val="solid"/>
-                      <a:round/>
-                      <a:headEnd type="none" w="med" len="med"/>
-                      <a:tailEnd type="none" w="med" len="med"/>
-                    </a:lnB>
-                    <a:solidFill>
-                      <a:srgbClr val="F0F4F5"/>
-                    </a:solidFill>
-                  </a:tcPr>
-                </a:tc>
-                <a:tc>
-                  <a:txBody>
-                    <a:bodyPr/>
-                    <a:lstStyle/>
-                    <a:p>
-                      <a:pPr indent="0" marL="0">
-                        <a:buNone/>
-                      </a:pPr>
-                      <a:r>
-                        <a:rPr lang="en-US" sz="950" dirty="0">
-                          <a:solidFill>
-                            <a:srgbClr val="5B6B73"/>
-                          </a:solidFill>
-                          <a:latin typeface="Calibri" pitchFamily="34" charset="0"/>
-                          <a:ea typeface="Calibri" pitchFamily="34" charset="-122"/>
-                          <a:cs typeface="Calibri" pitchFamily="34" charset="-120"/>
-                        </a:rPr>
-                        <a:t>Bem Estar/Segurança</a:t>
-                      </a:r>
-                      <a:endParaRPr lang="en-US" sz="950" dirty="0">
-                        <a:latin typeface="Calibri" charset="0"/>
-                        <a:ea typeface="Calibri" charset="0"/>
-                        <a:cs typeface="Calibri" charset="0"/>
-                      </a:endParaRPr>
-                    </a:p>
-                  </a:txBody>
-                  <a:tcPr marL="91440" marR="91440" marT="45720" marB="45720" anchor="ctr">
-                    <a:lnL w="6350" cap="flat" cmpd="sng" algn="ctr">
-                      <a:solidFill>
-                        <a:srgbClr val="E3E8E9"/>
-                      </a:solidFill>
-                      <a:prstDash val="solid"/>
-                      <a:round/>
-                      <a:headEnd type="none" w="med" len="med"/>
-                      <a:tailEnd type="none" w="med" len="med"/>
-                    </a:lnL>
-                    <a:lnR w="6350" cap="flat" cmpd="sng" algn="ctr">
-                      <a:solidFill>
-                        <a:srgbClr val="E3E8E9"/>
-                      </a:solidFill>
-                      <a:prstDash val="solid"/>
-                      <a:round/>
-                      <a:headEnd type="none" w="med" len="med"/>
-                      <a:tailEnd type="none" w="med" len="med"/>
-                    </a:lnR>
-                    <a:lnT w="6350" cap="flat" cmpd="sng" algn="ctr">
-                      <a:solidFill>
-                        <a:srgbClr val="E3E8E9"/>
-                      </a:solidFill>
-                      <a:prstDash val="solid"/>
-                      <a:round/>
-                      <a:headEnd type="none" w="med" len="med"/>
-                      <a:tailEnd type="none" w="med" len="med"/>
-                    </a:lnT>
-                    <a:lnB w="6350" cap="flat" cmpd="sng" algn="ctr">
-                      <a:solidFill>
-                        <a:srgbClr val="E3E8E9"/>
-                      </a:solidFill>
-                      <a:prstDash val="solid"/>
-                      <a:round/>
-                      <a:headEnd type="none" w="med" len="med"/>
-                      <a:tailEnd type="none" w="med" len="med"/>
-                    </a:lnB>
-                    <a:solidFill>
-                      <a:srgbClr val="F0F4F5"/>
-                    </a:solidFill>
-                  </a:tcPr>
-                </a:tc>
-                <a:tc>
-                  <a:txBody>
-                    <a:bodyPr/>
-                    <a:lstStyle/>
-                    <a:p>
-                      <a:pPr indent="0" marL="0">
-                        <a:buNone/>
-                      </a:pPr>
-                      <a:r>
-                        <a:rPr lang="en-US" sz="950" dirty="0">
-                          <a:solidFill>
-                            <a:srgbClr val="5B6B73"/>
-                          </a:solidFill>
-                          <a:latin typeface="Calibri" pitchFamily="34" charset="0"/>
-                          <a:ea typeface="Calibri" pitchFamily="34" charset="-122"/>
-                          <a:cs typeface="Calibri" pitchFamily="34" charset="-120"/>
-                        </a:rPr>
-                        <a:t>Projetos</a:t>
-                      </a:r>
-                      <a:endParaRPr lang="en-US" sz="950" dirty="0">
-                        <a:latin typeface="Calibri" charset="0"/>
-                        <a:ea typeface="Calibri" charset="0"/>
-                        <a:cs typeface="Calibri" charset="0"/>
-                      </a:endParaRPr>
-                    </a:p>
-                  </a:txBody>
-                  <a:tcPr marL="91440" marR="91440" marT="45720" marB="45720" anchor="ctr">
-                    <a:lnL w="6350" cap="flat" cmpd="sng" algn="ctr">
-                      <a:solidFill>
-                        <a:srgbClr val="E3E8E9"/>
-                      </a:solidFill>
-                      <a:prstDash val="solid"/>
-                      <a:round/>
-                      <a:headEnd type="none" w="med" len="med"/>
-                      <a:tailEnd type="none" w="med" len="med"/>
-                    </a:lnL>
-                    <a:lnR w="6350" cap="flat" cmpd="sng" algn="ctr">
-                      <a:solidFill>
-                        <a:srgbClr val="E3E8E9"/>
-                      </a:solidFill>
-                      <a:prstDash val="solid"/>
-                      <a:round/>
-                      <a:headEnd type="none" w="med" len="med"/>
-                      <a:tailEnd type="none" w="med" len="med"/>
-                    </a:lnR>
-                    <a:lnT w="6350" cap="flat" cmpd="sng" algn="ctr">
-                      <a:solidFill>
-                        <a:srgbClr val="E3E8E9"/>
-                      </a:solidFill>
-                      <a:prstDash val="solid"/>
-                      <a:round/>
-                      <a:headEnd type="none" w="med" len="med"/>
-                      <a:tailEnd type="none" w="med" len="med"/>
-                    </a:lnT>
-                    <a:lnB w="6350" cap="flat" cmpd="sng" algn="ctr">
-                      <a:solidFill>
-                        <a:srgbClr val="E3E8E9"/>
-                      </a:solidFill>
-                      <a:prstDash val="solid"/>
-                      <a:round/>
-                      <a:headEnd type="none" w="med" len="med"/>
-                      <a:tailEnd type="none" w="med" len="med"/>
-                    </a:lnB>
-                    <a:solidFill>
-                      <a:srgbClr val="F0F4F5"/>
-                    </a:solidFill>
-                  </a:tcPr>
-                </a:tc>
-                <a:tc>
-                  <a:txBody>
-                    <a:bodyPr/>
-                    <a:lstStyle/>
-                    <a:p>
-                      <a:pPr algn="r" indent="0" marL="0">
-                        <a:buNone/>
-                      </a:pPr>
-                      <a:r>
-                        <a:rPr lang="en-US" sz="1000" b="1" dirty="0">
-                          <a:solidFill>
-                            <a:srgbClr val="0B2A3D"/>
-                          </a:solidFill>
-                          <a:latin typeface="Calibri" pitchFamily="34" charset="0"/>
-                          <a:ea typeface="Calibri" pitchFamily="34" charset="-122"/>
-                          <a:cs typeface="Calibri" pitchFamily="34" charset="-120"/>
-                        </a:rPr>
-                        <a:t>US$ 500,0 mil</a:t>
+                        <a:t>US$ 500,7 mil</a:t>
                       </a:r>
                       <a:endParaRPr lang="en-US" sz="1000" dirty="0">
                         <a:latin typeface="Calibri" charset="0"/>
@@ -13165,7 +12617,7 @@
                           <a:ea typeface="Calibri" pitchFamily="34" charset="-122"/>
                           <a:cs typeface="Calibri" pitchFamily="34" charset="-120"/>
                         </a:rPr>
-                        <a:t>ESTUDOS DE ENGENHARIA</a:t>
+                        <a:t>SUBSTITUIÇÃO CABO SANSO - HAWSER WINCH</a:t>
                       </a:r>
                       <a:endParaRPr lang="en-US" sz="1000" dirty="0">
                         <a:latin typeface="Calibri" charset="0"/>
@@ -13233,7 +12685,7 @@
                           <a:ea typeface="Calibri" pitchFamily="34" charset="-122"/>
                           <a:cs typeface="Calibri" pitchFamily="34" charset="-120"/>
                         </a:rPr>
-                        <a:t>Eficiência de Produção</a:t>
+                        <a:t>Rotina Operacional</a:t>
                       </a:r>
                       <a:endParaRPr lang="en-US" sz="950" dirty="0">
                         <a:latin typeface="Calibri" charset="0"/>
@@ -13301,7 +12753,7 @@
                           <a:ea typeface="Calibri" pitchFamily="34" charset="-122"/>
                           <a:cs typeface="Calibri" pitchFamily="34" charset="-120"/>
                         </a:rPr>
-                        <a:t>Projetos</a:t>
+                        <a:t>NAV - Naval</a:t>
                       </a:r>
                       <a:endParaRPr lang="en-US" sz="950" dirty="0">
                         <a:latin typeface="Calibri" charset="0"/>
@@ -13369,7 +12821,7 @@
                           <a:ea typeface="Calibri" pitchFamily="34" charset="-122"/>
                           <a:cs typeface="Calibri" pitchFamily="34" charset="-120"/>
                         </a:rPr>
-                        <a:t>US$ 430,5 mil</a:t>
+                        <a:t>US$ 429,7 mil</a:t>
                       </a:r>
                       <a:endParaRPr lang="en-US" sz="1000" dirty="0">
                         <a:latin typeface="Calibri" charset="0"/>
@@ -13439,7 +12891,555 @@
                           <a:ea typeface="Calibri" pitchFamily="34" charset="-122"/>
                           <a:cs typeface="Calibri" pitchFamily="34" charset="-120"/>
                         </a:rPr>
-                        <a:t>SUBSTITUIÇÃO CABO SANSO - HAWSER WINCH</a:t>
+                        <a:t>Fabricação de Etiquetas de TAG - Código de Cores e Sentido de Fluxo</a:t>
+                      </a:r>
+                      <a:endParaRPr lang="en-US" sz="1000" dirty="0">
+                        <a:latin typeface="Calibri" charset="0"/>
+                        <a:ea typeface="Calibri" charset="0"/>
+                        <a:cs typeface="Calibri" charset="0"/>
+                      </a:endParaRPr>
+                    </a:p>
+                  </a:txBody>
+                  <a:tcPr marL="91440" marR="91440" marT="45720" marB="45720" anchor="ctr">
+                    <a:lnL w="6350" cap="flat" cmpd="sng" algn="ctr">
+                      <a:solidFill>
+                        <a:srgbClr val="E3E8E9"/>
+                      </a:solidFill>
+                      <a:prstDash val="solid"/>
+                      <a:round/>
+                      <a:headEnd type="none" w="med" len="med"/>
+                      <a:tailEnd type="none" w="med" len="med"/>
+                    </a:lnL>
+                    <a:lnR w="6350" cap="flat" cmpd="sng" algn="ctr">
+                      <a:solidFill>
+                        <a:srgbClr val="E3E8E9"/>
+                      </a:solidFill>
+                      <a:prstDash val="solid"/>
+                      <a:round/>
+                      <a:headEnd type="none" w="med" len="med"/>
+                      <a:tailEnd type="none" w="med" len="med"/>
+                    </a:lnR>
+                    <a:lnT w="6350" cap="flat" cmpd="sng" algn="ctr">
+                      <a:solidFill>
+                        <a:srgbClr val="E3E8E9"/>
+                      </a:solidFill>
+                      <a:prstDash val="solid"/>
+                      <a:round/>
+                      <a:headEnd type="none" w="med" len="med"/>
+                      <a:tailEnd type="none" w="med" len="med"/>
+                    </a:lnT>
+                    <a:lnB w="6350" cap="flat" cmpd="sng" algn="ctr">
+                      <a:solidFill>
+                        <a:srgbClr val="E3E8E9"/>
+                      </a:solidFill>
+                      <a:prstDash val="solid"/>
+                      <a:round/>
+                      <a:headEnd type="none" w="med" len="med"/>
+                      <a:tailEnd type="none" w="med" len="med"/>
+                    </a:lnB>
+                    <a:solidFill>
+                      <a:srgbClr val="FFFFFF"/>
+                    </a:solidFill>
+                  </a:tcPr>
+                </a:tc>
+                <a:tc>
+                  <a:txBody>
+                    <a:bodyPr/>
+                    <a:lstStyle/>
+                    <a:p>
+                      <a:pPr indent="0" marL="0">
+                        <a:buNone/>
+                      </a:pPr>
+                      <a:r>
+                        <a:rPr lang="en-US" sz="950" dirty="0">
+                          <a:solidFill>
+                            <a:srgbClr val="5B6B73"/>
+                          </a:solidFill>
+                          <a:latin typeface="Calibri" pitchFamily="34" charset="0"/>
+                          <a:ea typeface="Calibri" pitchFamily="34" charset="-122"/>
+                          <a:cs typeface="Calibri" pitchFamily="34" charset="-120"/>
+                        </a:rPr>
+                        <a:t>Integridade e Regulatório</a:t>
+                      </a:r>
+                      <a:endParaRPr lang="en-US" sz="950" dirty="0">
+                        <a:latin typeface="Calibri" charset="0"/>
+                        <a:ea typeface="Calibri" charset="0"/>
+                        <a:cs typeface="Calibri" charset="0"/>
+                      </a:endParaRPr>
+                    </a:p>
+                  </a:txBody>
+                  <a:tcPr marL="91440" marR="91440" marT="45720" marB="45720" anchor="ctr">
+                    <a:lnL w="6350" cap="flat" cmpd="sng" algn="ctr">
+                      <a:solidFill>
+                        <a:srgbClr val="E3E8E9"/>
+                      </a:solidFill>
+                      <a:prstDash val="solid"/>
+                      <a:round/>
+                      <a:headEnd type="none" w="med" len="med"/>
+                      <a:tailEnd type="none" w="med" len="med"/>
+                    </a:lnL>
+                    <a:lnR w="6350" cap="flat" cmpd="sng" algn="ctr">
+                      <a:solidFill>
+                        <a:srgbClr val="E3E8E9"/>
+                      </a:solidFill>
+                      <a:prstDash val="solid"/>
+                      <a:round/>
+                      <a:headEnd type="none" w="med" len="med"/>
+                      <a:tailEnd type="none" w="med" len="med"/>
+                    </a:lnR>
+                    <a:lnT w="6350" cap="flat" cmpd="sng" algn="ctr">
+                      <a:solidFill>
+                        <a:srgbClr val="E3E8E9"/>
+                      </a:solidFill>
+                      <a:prstDash val="solid"/>
+                      <a:round/>
+                      <a:headEnd type="none" w="med" len="med"/>
+                      <a:tailEnd type="none" w="med" len="med"/>
+                    </a:lnT>
+                    <a:lnB w="6350" cap="flat" cmpd="sng" algn="ctr">
+                      <a:solidFill>
+                        <a:srgbClr val="E3E8E9"/>
+                      </a:solidFill>
+                      <a:prstDash val="solid"/>
+                      <a:round/>
+                      <a:headEnd type="none" w="med" len="med"/>
+                      <a:tailEnd type="none" w="med" len="med"/>
+                    </a:lnB>
+                    <a:solidFill>
+                      <a:srgbClr val="FFFFFF"/>
+                    </a:solidFill>
+                  </a:tcPr>
+                </a:tc>
+                <a:tc>
+                  <a:txBody>
+                    <a:bodyPr/>
+                    <a:lstStyle/>
+                    <a:p>
+                      <a:pPr indent="0" marL="0">
+                        <a:buNone/>
+                      </a:pPr>
+                      <a:r>
+                        <a:rPr lang="en-US" sz="950" dirty="0">
+                          <a:solidFill>
+                            <a:srgbClr val="5B6B73"/>
+                          </a:solidFill>
+                          <a:latin typeface="Calibri" pitchFamily="34" charset="0"/>
+                          <a:ea typeface="Calibri" pitchFamily="34" charset="-122"/>
+                          <a:cs typeface="Calibri" pitchFamily="34" charset="-120"/>
+                        </a:rPr>
+                        <a:t>INT - Integridade</a:t>
+                      </a:r>
+                      <a:endParaRPr lang="en-US" sz="950" dirty="0">
+                        <a:latin typeface="Calibri" charset="0"/>
+                        <a:ea typeface="Calibri" charset="0"/>
+                        <a:cs typeface="Calibri" charset="0"/>
+                      </a:endParaRPr>
+                    </a:p>
+                  </a:txBody>
+                  <a:tcPr marL="91440" marR="91440" marT="45720" marB="45720" anchor="ctr">
+                    <a:lnL w="6350" cap="flat" cmpd="sng" algn="ctr">
+                      <a:solidFill>
+                        <a:srgbClr val="E3E8E9"/>
+                      </a:solidFill>
+                      <a:prstDash val="solid"/>
+                      <a:round/>
+                      <a:headEnd type="none" w="med" len="med"/>
+                      <a:tailEnd type="none" w="med" len="med"/>
+                    </a:lnL>
+                    <a:lnR w="6350" cap="flat" cmpd="sng" algn="ctr">
+                      <a:solidFill>
+                        <a:srgbClr val="E3E8E9"/>
+                      </a:solidFill>
+                      <a:prstDash val="solid"/>
+                      <a:round/>
+                      <a:headEnd type="none" w="med" len="med"/>
+                      <a:tailEnd type="none" w="med" len="med"/>
+                    </a:lnR>
+                    <a:lnT w="6350" cap="flat" cmpd="sng" algn="ctr">
+                      <a:solidFill>
+                        <a:srgbClr val="E3E8E9"/>
+                      </a:solidFill>
+                      <a:prstDash val="solid"/>
+                      <a:round/>
+                      <a:headEnd type="none" w="med" len="med"/>
+                      <a:tailEnd type="none" w="med" len="med"/>
+                    </a:lnT>
+                    <a:lnB w="6350" cap="flat" cmpd="sng" algn="ctr">
+                      <a:solidFill>
+                        <a:srgbClr val="E3E8E9"/>
+                      </a:solidFill>
+                      <a:prstDash val="solid"/>
+                      <a:round/>
+                      <a:headEnd type="none" w="med" len="med"/>
+                      <a:tailEnd type="none" w="med" len="med"/>
+                    </a:lnB>
+                    <a:solidFill>
+                      <a:srgbClr val="FFFFFF"/>
+                    </a:solidFill>
+                  </a:tcPr>
+                </a:tc>
+                <a:tc>
+                  <a:txBody>
+                    <a:bodyPr/>
+                    <a:lstStyle/>
+                    <a:p>
+                      <a:pPr algn="r" indent="0" marL="0">
+                        <a:buNone/>
+                      </a:pPr>
+                      <a:r>
+                        <a:rPr lang="en-US" sz="1000" b="1" dirty="0">
+                          <a:solidFill>
+                            <a:srgbClr val="0B2A3D"/>
+                          </a:solidFill>
+                          <a:latin typeface="Calibri" pitchFamily="34" charset="0"/>
+                          <a:ea typeface="Calibri" pitchFamily="34" charset="-122"/>
+                          <a:cs typeface="Calibri" pitchFamily="34" charset="-120"/>
+                        </a:rPr>
+                        <a:t>US$ 411,6 mil</a:t>
+                      </a:r>
+                      <a:endParaRPr lang="en-US" sz="1000" dirty="0">
+                        <a:latin typeface="Calibri" charset="0"/>
+                        <a:ea typeface="Calibri" charset="0"/>
+                        <a:cs typeface="Calibri" charset="0"/>
+                      </a:endParaRPr>
+                    </a:p>
+                  </a:txBody>
+                  <a:tcPr marL="91440" marR="91440" marT="45720" marB="45720" anchor="ctr">
+                    <a:lnL w="6350" cap="flat" cmpd="sng" algn="ctr">
+                      <a:solidFill>
+                        <a:srgbClr val="E3E8E9"/>
+                      </a:solidFill>
+                      <a:prstDash val="solid"/>
+                      <a:round/>
+                      <a:headEnd type="none" w="med" len="med"/>
+                      <a:tailEnd type="none" w="med" len="med"/>
+                    </a:lnL>
+                    <a:lnR w="6350" cap="flat" cmpd="sng" algn="ctr">
+                      <a:solidFill>
+                        <a:srgbClr val="E3E8E9"/>
+                      </a:solidFill>
+                      <a:prstDash val="solid"/>
+                      <a:round/>
+                      <a:headEnd type="none" w="med" len="med"/>
+                      <a:tailEnd type="none" w="med" len="med"/>
+                    </a:lnR>
+                    <a:lnT w="6350" cap="flat" cmpd="sng" algn="ctr">
+                      <a:solidFill>
+                        <a:srgbClr val="E3E8E9"/>
+                      </a:solidFill>
+                      <a:prstDash val="solid"/>
+                      <a:round/>
+                      <a:headEnd type="none" w="med" len="med"/>
+                      <a:tailEnd type="none" w="med" len="med"/>
+                    </a:lnT>
+                    <a:lnB w="6350" cap="flat" cmpd="sng" algn="ctr">
+                      <a:solidFill>
+                        <a:srgbClr val="E3E8E9"/>
+                      </a:solidFill>
+                      <a:prstDash val="solid"/>
+                      <a:round/>
+                      <a:headEnd type="none" w="med" len="med"/>
+                      <a:tailEnd type="none" w="med" len="med"/>
+                    </a:lnB>
+                    <a:solidFill>
+                      <a:srgbClr val="FFFFFF"/>
+                    </a:solidFill>
+                  </a:tcPr>
+                </a:tc>
+              </a:tr>
+              <a:tr h="288036">
+                <a:tc>
+                  <a:txBody>
+                    <a:bodyPr/>
+                    <a:lstStyle/>
+                    <a:p>
+                      <a:pPr indent="0" marL="0">
+                        <a:buNone/>
+                      </a:pPr>
+                      <a:r>
+                        <a:rPr lang="en-US" sz="1000" dirty="0">
+                          <a:solidFill>
+                            <a:srgbClr val="1C2B33"/>
+                          </a:solidFill>
+                          <a:latin typeface="Calibri" pitchFamily="34" charset="0"/>
+                          <a:ea typeface="Calibri" pitchFamily="34" charset="-122"/>
+                          <a:cs typeface="Calibri" pitchFamily="34" charset="-120"/>
+                        </a:rPr>
+                        <a:t>NOVOS PAINÉIS ICCP</a:t>
+                      </a:r>
+                      <a:endParaRPr lang="en-US" sz="1000" dirty="0">
+                        <a:latin typeface="Calibri" charset="0"/>
+                        <a:ea typeface="Calibri" charset="0"/>
+                        <a:cs typeface="Calibri" charset="0"/>
+                      </a:endParaRPr>
+                    </a:p>
+                  </a:txBody>
+                  <a:tcPr marL="91440" marR="91440" marT="45720" marB="45720" anchor="ctr">
+                    <a:lnL w="6350" cap="flat" cmpd="sng" algn="ctr">
+                      <a:solidFill>
+                        <a:srgbClr val="E3E8E9"/>
+                      </a:solidFill>
+                      <a:prstDash val="solid"/>
+                      <a:round/>
+                      <a:headEnd type="none" w="med" len="med"/>
+                      <a:tailEnd type="none" w="med" len="med"/>
+                    </a:lnL>
+                    <a:lnR w="6350" cap="flat" cmpd="sng" algn="ctr">
+                      <a:solidFill>
+                        <a:srgbClr val="E3E8E9"/>
+                      </a:solidFill>
+                      <a:prstDash val="solid"/>
+                      <a:round/>
+                      <a:headEnd type="none" w="med" len="med"/>
+                      <a:tailEnd type="none" w="med" len="med"/>
+                    </a:lnR>
+                    <a:lnT w="6350" cap="flat" cmpd="sng" algn="ctr">
+                      <a:solidFill>
+                        <a:srgbClr val="E3E8E9"/>
+                      </a:solidFill>
+                      <a:prstDash val="solid"/>
+                      <a:round/>
+                      <a:headEnd type="none" w="med" len="med"/>
+                      <a:tailEnd type="none" w="med" len="med"/>
+                    </a:lnT>
+                    <a:lnB w="6350" cap="flat" cmpd="sng" algn="ctr">
+                      <a:solidFill>
+                        <a:srgbClr val="E3E8E9"/>
+                      </a:solidFill>
+                      <a:prstDash val="solid"/>
+                      <a:round/>
+                      <a:headEnd type="none" w="med" len="med"/>
+                      <a:tailEnd type="none" w="med" len="med"/>
+                    </a:lnB>
+                    <a:solidFill>
+                      <a:srgbClr val="F0F4F5"/>
+                    </a:solidFill>
+                  </a:tcPr>
+                </a:tc>
+                <a:tc>
+                  <a:txBody>
+                    <a:bodyPr/>
+                    <a:lstStyle/>
+                    <a:p>
+                      <a:pPr indent="0" marL="0">
+                        <a:buNone/>
+                      </a:pPr>
+                      <a:r>
+                        <a:rPr lang="en-US" sz="950" dirty="0">
+                          <a:solidFill>
+                            <a:srgbClr val="5B6B73"/>
+                          </a:solidFill>
+                          <a:latin typeface="Calibri" pitchFamily="34" charset="0"/>
+                          <a:ea typeface="Calibri" pitchFamily="34" charset="-122"/>
+                          <a:cs typeface="Calibri" pitchFamily="34" charset="-120"/>
+                        </a:rPr>
+                        <a:t>Rotina Operacional</a:t>
+                      </a:r>
+                      <a:endParaRPr lang="en-US" sz="950" dirty="0">
+                        <a:latin typeface="Calibri" charset="0"/>
+                        <a:ea typeface="Calibri" charset="0"/>
+                        <a:cs typeface="Calibri" charset="0"/>
+                      </a:endParaRPr>
+                    </a:p>
+                  </a:txBody>
+                  <a:tcPr marL="91440" marR="91440" marT="45720" marB="45720" anchor="ctr">
+                    <a:lnL w="6350" cap="flat" cmpd="sng" algn="ctr">
+                      <a:solidFill>
+                        <a:srgbClr val="E3E8E9"/>
+                      </a:solidFill>
+                      <a:prstDash val="solid"/>
+                      <a:round/>
+                      <a:headEnd type="none" w="med" len="med"/>
+                      <a:tailEnd type="none" w="med" len="med"/>
+                    </a:lnL>
+                    <a:lnR w="6350" cap="flat" cmpd="sng" algn="ctr">
+                      <a:solidFill>
+                        <a:srgbClr val="E3E8E9"/>
+                      </a:solidFill>
+                      <a:prstDash val="solid"/>
+                      <a:round/>
+                      <a:headEnd type="none" w="med" len="med"/>
+                      <a:tailEnd type="none" w="med" len="med"/>
+                    </a:lnR>
+                    <a:lnT w="6350" cap="flat" cmpd="sng" algn="ctr">
+                      <a:solidFill>
+                        <a:srgbClr val="E3E8E9"/>
+                      </a:solidFill>
+                      <a:prstDash val="solid"/>
+                      <a:round/>
+                      <a:headEnd type="none" w="med" len="med"/>
+                      <a:tailEnd type="none" w="med" len="med"/>
+                    </a:lnT>
+                    <a:lnB w="6350" cap="flat" cmpd="sng" algn="ctr">
+                      <a:solidFill>
+                        <a:srgbClr val="E3E8E9"/>
+                      </a:solidFill>
+                      <a:prstDash val="solid"/>
+                      <a:round/>
+                      <a:headEnd type="none" w="med" len="med"/>
+                      <a:tailEnd type="none" w="med" len="med"/>
+                    </a:lnB>
+                    <a:solidFill>
+                      <a:srgbClr val="F0F4F5"/>
+                    </a:solidFill>
+                  </a:tcPr>
+                </a:tc>
+                <a:tc>
+                  <a:txBody>
+                    <a:bodyPr/>
+                    <a:lstStyle/>
+                    <a:p>
+                      <a:pPr indent="0" marL="0">
+                        <a:buNone/>
+                      </a:pPr>
+                      <a:r>
+                        <a:rPr lang="en-US" sz="950" dirty="0">
+                          <a:solidFill>
+                            <a:srgbClr val="5B6B73"/>
+                          </a:solidFill>
+                          <a:latin typeface="Calibri" pitchFamily="34" charset="0"/>
+                          <a:ea typeface="Calibri" pitchFamily="34" charset="-122"/>
+                          <a:cs typeface="Calibri" pitchFamily="34" charset="-120"/>
+                        </a:rPr>
+                        <a:t>MNT – Manutenção</a:t>
+                      </a:r>
+                      <a:endParaRPr lang="en-US" sz="950" dirty="0">
+                        <a:latin typeface="Calibri" charset="0"/>
+                        <a:ea typeface="Calibri" charset="0"/>
+                        <a:cs typeface="Calibri" charset="0"/>
+                      </a:endParaRPr>
+                    </a:p>
+                  </a:txBody>
+                  <a:tcPr marL="91440" marR="91440" marT="45720" marB="45720" anchor="ctr">
+                    <a:lnL w="6350" cap="flat" cmpd="sng" algn="ctr">
+                      <a:solidFill>
+                        <a:srgbClr val="E3E8E9"/>
+                      </a:solidFill>
+                      <a:prstDash val="solid"/>
+                      <a:round/>
+                      <a:headEnd type="none" w="med" len="med"/>
+                      <a:tailEnd type="none" w="med" len="med"/>
+                    </a:lnL>
+                    <a:lnR w="6350" cap="flat" cmpd="sng" algn="ctr">
+                      <a:solidFill>
+                        <a:srgbClr val="E3E8E9"/>
+                      </a:solidFill>
+                      <a:prstDash val="solid"/>
+                      <a:round/>
+                      <a:headEnd type="none" w="med" len="med"/>
+                      <a:tailEnd type="none" w="med" len="med"/>
+                    </a:lnR>
+                    <a:lnT w="6350" cap="flat" cmpd="sng" algn="ctr">
+                      <a:solidFill>
+                        <a:srgbClr val="E3E8E9"/>
+                      </a:solidFill>
+                      <a:prstDash val="solid"/>
+                      <a:round/>
+                      <a:headEnd type="none" w="med" len="med"/>
+                      <a:tailEnd type="none" w="med" len="med"/>
+                    </a:lnT>
+                    <a:lnB w="6350" cap="flat" cmpd="sng" algn="ctr">
+                      <a:solidFill>
+                        <a:srgbClr val="E3E8E9"/>
+                      </a:solidFill>
+                      <a:prstDash val="solid"/>
+                      <a:round/>
+                      <a:headEnd type="none" w="med" len="med"/>
+                      <a:tailEnd type="none" w="med" len="med"/>
+                    </a:lnB>
+                    <a:solidFill>
+                      <a:srgbClr val="F0F4F5"/>
+                    </a:solidFill>
+                  </a:tcPr>
+                </a:tc>
+                <a:tc>
+                  <a:txBody>
+                    <a:bodyPr/>
+                    <a:lstStyle/>
+                    <a:p>
+                      <a:pPr algn="r" indent="0" marL="0">
+                        <a:buNone/>
+                      </a:pPr>
+                      <a:r>
+                        <a:rPr lang="en-US" sz="1000" b="1" dirty="0">
+                          <a:solidFill>
+                            <a:srgbClr val="0B2A3D"/>
+                          </a:solidFill>
+                          <a:latin typeface="Calibri" pitchFamily="34" charset="0"/>
+                          <a:ea typeface="Calibri" pitchFamily="34" charset="-122"/>
+                          <a:cs typeface="Calibri" pitchFamily="34" charset="-120"/>
+                        </a:rPr>
+                        <a:t>US$ 409,5 mil</a:t>
+                      </a:r>
+                      <a:endParaRPr lang="en-US" sz="1000" dirty="0">
+                        <a:latin typeface="Calibri" charset="0"/>
+                        <a:ea typeface="Calibri" charset="0"/>
+                        <a:cs typeface="Calibri" charset="0"/>
+                      </a:endParaRPr>
+                    </a:p>
+                  </a:txBody>
+                  <a:tcPr marL="91440" marR="91440" marT="45720" marB="45720" anchor="ctr">
+                    <a:lnL w="6350" cap="flat" cmpd="sng" algn="ctr">
+                      <a:solidFill>
+                        <a:srgbClr val="E3E8E9"/>
+                      </a:solidFill>
+                      <a:prstDash val="solid"/>
+                      <a:round/>
+                      <a:headEnd type="none" w="med" len="med"/>
+                      <a:tailEnd type="none" w="med" len="med"/>
+                    </a:lnL>
+                    <a:lnR w="6350" cap="flat" cmpd="sng" algn="ctr">
+                      <a:solidFill>
+                        <a:srgbClr val="E3E8E9"/>
+                      </a:solidFill>
+                      <a:prstDash val="solid"/>
+                      <a:round/>
+                      <a:headEnd type="none" w="med" len="med"/>
+                      <a:tailEnd type="none" w="med" len="med"/>
+                    </a:lnR>
+                    <a:lnT w="6350" cap="flat" cmpd="sng" algn="ctr">
+                      <a:solidFill>
+                        <a:srgbClr val="E3E8E9"/>
+                      </a:solidFill>
+                      <a:prstDash val="solid"/>
+                      <a:round/>
+                      <a:headEnd type="none" w="med" len="med"/>
+                      <a:tailEnd type="none" w="med" len="med"/>
+                    </a:lnT>
+                    <a:lnB w="6350" cap="flat" cmpd="sng" algn="ctr">
+                      <a:solidFill>
+                        <a:srgbClr val="E3E8E9"/>
+                      </a:solidFill>
+                      <a:prstDash val="solid"/>
+                      <a:round/>
+                      <a:headEnd type="none" w="med" len="med"/>
+                      <a:tailEnd type="none" w="med" len="med"/>
+                    </a:lnB>
+                    <a:solidFill>
+                      <a:srgbClr val="F0F4F5"/>
+                    </a:solidFill>
+                  </a:tcPr>
+                </a:tc>
+              </a:tr>
+              <a:tr h="288036">
+                <a:tc>
+                  <a:txBody>
+                    <a:bodyPr/>
+                    <a:lstStyle/>
+                    <a:p>
+                      <a:pPr indent="0" marL="0">
+                        <a:buNone/>
+                      </a:pPr>
+                      <a:r>
+                        <a:rPr lang="en-US" sz="1000" dirty="0">
+                          <a:solidFill>
+                            <a:srgbClr val="1C2B33"/>
+                          </a:solidFill>
+                          <a:latin typeface="Calibri" pitchFamily="34" charset="0"/>
+                          <a:ea typeface="Calibri" pitchFamily="34" charset="-122"/>
+                          <a:cs typeface="Calibri" pitchFamily="34" charset="-120"/>
+                        </a:rPr>
+                        <a:t>Instalação e Comissionamento OSPREY</a:t>
                       </a:r>
                       <a:endParaRPr lang="en-US" sz="1000" dirty="0">
                         <a:latin typeface="Calibri" charset="0"/>
@@ -13575,7 +13575,7 @@
                           <a:ea typeface="Calibri" pitchFamily="34" charset="-122"/>
                           <a:cs typeface="Calibri" pitchFamily="34" charset="-120"/>
                         </a:rPr>
-                        <a:t>NAV - Naval</a:t>
+                        <a:t>MNT – Manutenção</a:t>
                       </a:r>
                       <a:endParaRPr lang="en-US" sz="950" dirty="0">
                         <a:latin typeface="Calibri" charset="0"/>
@@ -13643,7 +13643,7 @@
                           <a:ea typeface="Calibri" pitchFamily="34" charset="-122"/>
                           <a:cs typeface="Calibri" pitchFamily="34" charset="-120"/>
                         </a:rPr>
-                        <a:t>US$ 429,7 mil</a:t>
+                        <a:t>US$ 380,0 mil</a:t>
                       </a:r>
                       <a:endParaRPr lang="en-US" sz="1000" dirty="0">
                         <a:latin typeface="Calibri" charset="0"/>
@@ -13713,7 +13713,7 @@
                           <a:ea typeface="Calibri" pitchFamily="34" charset="-122"/>
                           <a:cs typeface="Calibri" pitchFamily="34" charset="-120"/>
                         </a:rPr>
-                        <a:t>Outros 62 escopos (itens de menor valor individual)</a:t>
+                        <a:t>Outros 44 escopos (itens de menor valor individual)</a:t>
                       </a:r>
                       <a:endParaRPr lang="en-US" sz="950" dirty="0">
                         <a:latin typeface="Calibri" charset="0"/>
@@ -13787,7 +13787,7 @@
                           <a:ea typeface="Calibri" pitchFamily="34" charset="-122"/>
                           <a:cs typeface="Calibri" pitchFamily="34" charset="-120"/>
                         </a:rPr>
-                        <a:t>US$ 8,7 mi</a:t>
+                        <a:t>US$ 6,5 mi</a:t>
                       </a:r>
                       <a:endParaRPr lang="en-US" sz="1000" dirty="0">
                         <a:latin typeface="Calibri" charset="0"/>

</xml_diff>